<commit_message>
Add Query Parameters box to schema figure
Shows three counting modes (unique_cnt, total_cnt, instances) and
configurable clone size threshold in the center column.

Co-Authored-By: Claude Opus 4.6 <noreply@anthropic.com>
Claude-Session: https://claude.ai/code/session_01D55fsgxxDUfDTuPfRhF34U
</commit_message>
<xml_diff>
--- a/IS-API_Schema_Fig.pptx
+++ b/IS-API_Schema_Fig.pptx
@@ -10,8 +10,8 @@
   <p:notesMasterIdLst>
     <p:notesMasterId r:id="rId3"/>
   </p:notesMasterIdLst>
-  <p:sldSz cx="12188952" cy="9144000"/>
-  <p:notesSz cx="9144000" cy="12188952"/>
+  <p:sldSz cx="12188952" cy="9784080"/>
+  <p:notesSz cx="9784080" cy="12188952"/>
   <p:defaultTextStyle>
     <a:lvl1pPr marL="0" algn="l" defTabSz="914400" rtl="0" eaLnBrk="1" latinLnBrk="0" hangingPunct="1">
       <a:defRPr sz="1800" kern="1200">
@@ -2333,21 +2333,21 @@
         <p:spPr>
           <a:xfrm>
             <a:off x="4343400" y="3474720"/>
-            <a:ext cx="3200400" cy="548640"/>
+            <a:ext cx="3200400" cy="1188720"/>
           </a:xfrm>
           <a:prstGeom prst="roundRect">
             <a:avLst>
-              <a:gd name="adj" fmla="val 8333"/>
+              <a:gd name="adj" fmla="val 3846"/>
             </a:avLst>
           </a:prstGeom>
           <a:solidFill>
             <a:srgbClr val="E8F1F8"/>
           </a:solidFill>
-          <a:ln w="8890">
+          <a:ln w="10160">
             <a:solidFill>
               <a:srgbClr val="2D6A8F"/>
             </a:solidFill>
-            <a:prstDash val="dash"/>
+            <a:prstDash val="solid"/>
           </a:ln>
         </p:spPr>
       </p:sp>
@@ -2360,7 +2360,46 @@
         <p:spPr>
           <a:xfrm>
             <a:off x="4434840" y="3520440"/>
-            <a:ext cx="3017520" cy="457200"/>
+            <a:ext cx="3017520" cy="201168"/>
+          </a:xfrm>
+          <a:prstGeom prst="rect">
+            <a:avLst/>
+          </a:prstGeom>
+          <a:noFill/>
+          <a:ln/>
+        </p:spPr>
+        <p:txBody>
+          <a:bodyPr wrap="square" lIns="0" tIns="0" rIns="0" bIns="0" rtlCol="0" anchor="ctr"/>
+          <a:lstStyle/>
+          <a:p>
+            <a:pPr indent="0" marL="0">
+              <a:buNone/>
+            </a:pPr>
+            <a:r>
+              <a:rPr lang="en-US" sz="1000" b="1" dirty="0">
+                <a:solidFill>
+                  <a:srgbClr val="2D6A8F"/>
+                </a:solidFill>
+                <a:latin typeface="Calibri" pitchFamily="34" charset="0"/>
+                <a:ea typeface="Calibri" pitchFamily="34" charset="-122"/>
+                <a:cs typeface="Calibri" pitchFamily="34" charset="-120"/>
+              </a:rPr>
+              <a:t>Query Parameters</a:t>
+            </a:r>
+            <a:endParaRPr lang="en-US" sz="1000" dirty="0"/>
+          </a:p>
+        </p:txBody>
+      </p:sp>
+      <p:sp>
+        <p:nvSpPr>
+          <p:cNvPr id="45" name="Text 43"/>
+          <p:cNvSpPr/>
+          <p:nvPr/>
+        </p:nvSpPr>
+        <p:spPr>
+          <a:xfrm>
+            <a:off x="4434840" y="3749040"/>
+            <a:ext cx="3017520" cy="868680"/>
           </a:xfrm>
           <a:prstGeom prst="rect">
             <a:avLst/>
@@ -2374,47 +2413,179 @@
           <a:p>
             <a:pPr indent="0" marL="0">
               <a:lnSpc>
-                <a:spcPct val="110000"/>
+                <a:spcPct val="105000"/>
               </a:lnSpc>
               <a:buNone/>
             </a:pPr>
             <a:r>
-              <a:rPr lang="en-US" sz="850" dirty="0">
-                <a:solidFill>
-                  <a:srgbClr val="4A5B70"/>
-                </a:solidFill>
-              </a:rPr>
-              <a:t>• Queries all databases in parallel
+              <a:rPr lang="en-US" sz="850" b="1" dirty="0">
+                <a:solidFill>
+                  <a:srgbClr val="1A2744"/>
+                </a:solidFill>
+                <a:latin typeface="Courier New" pitchFamily="34" charset="0"/>
+                <a:ea typeface="Courier New" pitchFamily="34" charset="-122"/>
+                <a:cs typeface="Courier New" pitchFamily="34" charset="-120"/>
+              </a:rPr>
+              <a:t>Counting mode
 </a:t>
             </a:r>
             <a:pPr indent="0" marL="0">
               <a:lnSpc>
-                <a:spcPct val="110000"/>
+                <a:spcPct val="105000"/>
               </a:lnSpc>
               <a:buNone/>
             </a:pPr>
             <a:r>
-              <a:rPr lang="en-US" sz="850" dirty="0">
+              <a:rPr lang="en-US" sz="800" dirty="0">
                 <a:solidFill>
                   <a:srgbClr val="4A5B70"/>
                 </a:solidFill>
-              </a:rPr>
-              <a:t>• Filters by metadata key/value
-</a:t>
+                <a:latin typeface="Courier New" pitchFamily="34" charset="0"/>
+                <a:ea typeface="Courier New" pitchFamily="34" charset="-122"/>
+                <a:cs typeface="Courier New" pitchFamily="34" charset="-120"/>
+              </a:rPr>
+              <a:t>  unique_cnt  </a:t>
             </a:r>
             <a:pPr indent="0" marL="0">
               <a:lnSpc>
-                <a:spcPct val="110000"/>
+                <a:spcPct val="105000"/>
               </a:lnSpc>
               <a:buNone/>
             </a:pPr>
             <a:r>
-              <a:rPr lang="en-US" sz="850" dirty="0">
+              <a:rPr lang="en-US" sz="800" dirty="0">
                 <a:solidFill>
                   <a:srgbClr val="4A5B70"/>
                 </a:solidFill>
               </a:rPr>
-              <a:t>• Returns unified JSON per subject</a:t>
+              <a:t>unique sequences
+</a:t>
+            </a:r>
+            <a:pPr indent="0" marL="0">
+              <a:lnSpc>
+                <a:spcPct val="105000"/>
+              </a:lnSpc>
+              <a:buNone/>
+            </a:pPr>
+            <a:r>
+              <a:rPr lang="en-US" sz="800" dirty="0">
+                <a:solidFill>
+                  <a:srgbClr val="4A5B70"/>
+                </a:solidFill>
+                <a:latin typeface="Courier New" pitchFamily="34" charset="0"/>
+                <a:ea typeface="Courier New" pitchFamily="34" charset="-122"/>
+                <a:cs typeface="Courier New" pitchFamily="34" charset="-120"/>
+              </a:rPr>
+              <a:t>  total_cnt   </a:t>
+            </a:r>
+            <a:pPr indent="0" marL="0">
+              <a:lnSpc>
+                <a:spcPct val="105000"/>
+              </a:lnSpc>
+              <a:buNone/>
+            </a:pPr>
+            <a:r>
+              <a:rPr lang="en-US" sz="800" dirty="0">
+                <a:solidFill>
+                  <a:srgbClr val="4A5B70"/>
+                </a:solidFill>
+              </a:rPr>
+              <a:t>copies / reads
+</a:t>
+            </a:r>
+            <a:pPr indent="0" marL="0">
+              <a:lnSpc>
+                <a:spcPct val="105000"/>
+              </a:lnSpc>
+              <a:buNone/>
+            </a:pPr>
+            <a:r>
+              <a:rPr lang="en-US" sz="800" dirty="0">
+                <a:solidFill>
+                  <a:srgbClr val="4A5B70"/>
+                </a:solidFill>
+                <a:latin typeface="Courier New" pitchFamily="34" charset="0"/>
+                <a:ea typeface="Courier New" pitchFamily="34" charset="-122"/>
+                <a:cs typeface="Courier New" pitchFamily="34" charset="-120"/>
+              </a:rPr>
+              <a:t>  instances   </a:t>
+            </a:r>
+            <a:pPr indent="0" marL="0">
+              <a:lnSpc>
+                <a:spcPct val="105000"/>
+              </a:lnSpc>
+              <a:buNone/>
+            </a:pPr>
+            <a:r>
+              <a:rPr lang="en-US" sz="800" dirty="0">
+                <a:solidFill>
+                  <a:srgbClr val="4A5B70"/>
+                </a:solidFill>
+              </a:rPr>
+              <a:t>clone occurrences
+</a:t>
+            </a:r>
+            <a:pPr indent="0" marL="0">
+              <a:lnSpc>
+                <a:spcPct val="105000"/>
+              </a:lnSpc>
+              <a:buNone/>
+            </a:pPr>
+            <a:r>
+              <a:rPr lang="en-US" sz="400" dirty="0">
+                <a:solidFill>
+                  <a:srgbClr val="000000"/>
+                </a:solidFill>
+              </a:rPr>
+              <a:t>
+</a:t>
+            </a:r>
+            <a:pPr indent="0" marL="0">
+              <a:lnSpc>
+                <a:spcPct val="105000"/>
+              </a:lnSpc>
+              <a:buNone/>
+            </a:pPr>
+            <a:r>
+              <a:rPr lang="en-US" sz="850" b="1" dirty="0">
+                <a:solidFill>
+                  <a:srgbClr val="1A2744"/>
+                </a:solidFill>
+                <a:latin typeface="Courier New" pitchFamily="34" charset="0"/>
+                <a:ea typeface="Courier New" pitchFamily="34" charset="-122"/>
+                <a:cs typeface="Courier New" pitchFamily="34" charset="-120"/>
+              </a:rPr>
+              <a:t>Clone size threshold
+</a:t>
+            </a:r>
+            <a:pPr indent="0" marL="0">
+              <a:lnSpc>
+                <a:spcPct val="105000"/>
+              </a:lnSpc>
+              <a:buNone/>
+            </a:pPr>
+            <a:r>
+              <a:rPr lang="en-US" sz="800" dirty="0">
+                <a:solidFill>
+                  <a:srgbClr val="4A5B70"/>
+                </a:solidFill>
+              </a:rPr>
+              <a:t>  configurable min. clone size
+</a:t>
+            </a:r>
+            <a:pPr indent="0" marL="0">
+              <a:lnSpc>
+                <a:spcPct val="105000"/>
+              </a:lnSpc>
+              <a:buNone/>
+            </a:pPr>
+            <a:r>
+              <a:rPr lang="en-US" sz="800" dirty="0">
+                <a:solidFill>
+                  <a:srgbClr val="4A5B70"/>
+                </a:solidFill>
+              </a:rPr>
+              <a:t>  (default: ≥20 unique seqs)</a:t>
             </a:r>
             <a:endParaRPr lang="en-US" sz="850" dirty="0"/>
           </a:p>
@@ -2422,7 +2593,7 @@
       </p:sp>
       <p:sp>
         <p:nvSpPr>
-          <p:cNvPr id="45" name="Shape 43"/>
+          <p:cNvPr id="46" name="Shape 44"/>
           <p:cNvSpPr/>
           <p:nvPr/>
         </p:nvSpPr>
@@ -2442,7 +2613,7 @@
       </p:sp>
       <p:sp>
         <p:nvSpPr>
-          <p:cNvPr id="46" name="Shape 44"/>
+          <p:cNvPr id="47" name="Shape 45"/>
           <p:cNvSpPr/>
           <p:nvPr/>
         </p:nvSpPr>
@@ -2464,7 +2635,7 @@
       </p:sp>
       <p:sp>
         <p:nvSpPr>
-          <p:cNvPr id="47" name="Text 45"/>
+          <p:cNvPr id="48" name="Text 46"/>
           <p:cNvSpPr/>
           <p:nvPr/>
         </p:nvSpPr>
@@ -2503,7 +2674,7 @@
       </p:sp>
       <p:sp>
         <p:nvSpPr>
-          <p:cNvPr id="48" name="Shape 46"/>
+          <p:cNvPr id="49" name="Shape 47"/>
           <p:cNvSpPr/>
           <p:nvPr/>
         </p:nvSpPr>
@@ -2530,7 +2701,7 @@
       </p:sp>
       <p:sp>
         <p:nvSpPr>
-          <p:cNvPr id="49" name="Text 47"/>
+          <p:cNvPr id="50" name="Text 48"/>
           <p:cNvSpPr/>
           <p:nvPr/>
         </p:nvSpPr>
@@ -2569,7 +2740,7 @@
       </p:sp>
       <p:sp>
         <p:nvSpPr>
-          <p:cNvPr id="50" name="Text 48"/>
+          <p:cNvPr id="51" name="Text 49"/>
           <p:cNvSpPr/>
           <p:nvPr/>
         </p:nvSpPr>
@@ -2689,7 +2860,7 @@
       </p:sp>
       <p:sp>
         <p:nvSpPr>
-          <p:cNvPr id="51" name="Shape 49"/>
+          <p:cNvPr id="52" name="Shape 50"/>
           <p:cNvSpPr/>
           <p:nvPr/>
         </p:nvSpPr>
@@ -2716,7 +2887,7 @@
       </p:sp>
       <p:sp>
         <p:nvSpPr>
-          <p:cNvPr id="52" name="Text 50"/>
+          <p:cNvPr id="53" name="Text 51"/>
           <p:cNvSpPr/>
           <p:nvPr/>
         </p:nvSpPr>
@@ -2755,7 +2926,7 @@
       </p:sp>
       <p:sp>
         <p:nvSpPr>
-          <p:cNvPr id="53" name="Text 51"/>
+          <p:cNvPr id="54" name="Text 52"/>
           <p:cNvSpPr/>
           <p:nvPr/>
         </p:nvSpPr>
@@ -2843,7 +3014,7 @@
       </p:sp>
       <p:sp>
         <p:nvSpPr>
-          <p:cNvPr id="54" name="Shape 52"/>
+          <p:cNvPr id="55" name="Shape 53"/>
           <p:cNvSpPr/>
           <p:nvPr/>
         </p:nvSpPr>
@@ -2870,7 +3041,7 @@
       </p:sp>
       <p:sp>
         <p:nvSpPr>
-          <p:cNvPr id="55" name="Text 53"/>
+          <p:cNvPr id="56" name="Text 54"/>
           <p:cNvSpPr/>
           <p:nvPr/>
         </p:nvSpPr>
@@ -2909,7 +3080,7 @@
       </p:sp>
       <p:sp>
         <p:nvSpPr>
-          <p:cNvPr id="56" name="Text 54"/>
+          <p:cNvPr id="57" name="Text 55"/>
           <p:cNvSpPr/>
           <p:nvPr/>
         </p:nvSpPr>
@@ -3061,13 +3232,13 @@
       </p:sp>
       <p:sp>
         <p:nvSpPr>
-          <p:cNvPr id="57" name="Text 55"/>
-          <p:cNvSpPr/>
-          <p:nvPr/>
-        </p:nvSpPr>
-        <p:spPr>
-          <a:xfrm>
-            <a:off x="228600" y="4343400"/>
+          <p:cNvPr id="58" name="Text 56"/>
+          <p:cNvSpPr/>
+          <p:nvPr/>
+        </p:nvSpPr>
+        <p:spPr>
+          <a:xfrm>
+            <a:off x="228600" y="4937760"/>
             <a:ext cx="320040" cy="320040"/>
           </a:xfrm>
           <a:prstGeom prst="rect">
@@ -3100,13 +3271,13 @@
       </p:sp>
       <p:sp>
         <p:nvSpPr>
-          <p:cNvPr id="58" name="Text 56"/>
-          <p:cNvSpPr/>
-          <p:nvPr/>
-        </p:nvSpPr>
-        <p:spPr>
-          <a:xfrm>
-            <a:off x="548640" y="4343400"/>
+          <p:cNvPr id="59" name="Text 57"/>
+          <p:cNvSpPr/>
+          <p:nvPr/>
+        </p:nvSpPr>
+        <p:spPr>
+          <a:xfrm>
+            <a:off x="548640" y="4937760"/>
             <a:ext cx="5486400" cy="320040"/>
           </a:xfrm>
           <a:prstGeom prst="rect">
@@ -3139,13 +3310,13 @@
       </p:sp>
       <p:sp>
         <p:nvSpPr>
-          <p:cNvPr id="59" name="Text 57"/>
-          <p:cNvSpPr/>
-          <p:nvPr/>
-        </p:nvSpPr>
-        <p:spPr>
-          <a:xfrm>
-            <a:off x="274320" y="4663440"/>
+          <p:cNvPr id="60" name="Text 58"/>
+          <p:cNvSpPr/>
+          <p:nvPr/>
+        </p:nvSpPr>
+        <p:spPr>
+          <a:xfrm>
+            <a:off x="274320" y="5257800"/>
             <a:ext cx="11612880" cy="274320"/>
           </a:xfrm>
           <a:prstGeom prst="rect">
@@ -3178,13 +3349,13 @@
       </p:sp>
       <p:sp>
         <p:nvSpPr>
-          <p:cNvPr id="60" name="Shape 58"/>
-          <p:cNvSpPr/>
-          <p:nvPr/>
-        </p:nvSpPr>
-        <p:spPr>
-          <a:xfrm>
-            <a:off x="274320" y="5029200"/>
+          <p:cNvPr id="61" name="Shape 59"/>
+          <p:cNvSpPr/>
+          <p:nvPr/>
+        </p:nvSpPr>
+        <p:spPr>
+          <a:xfrm>
+            <a:off x="274320" y="5623560"/>
             <a:ext cx="2560320" cy="438912"/>
           </a:xfrm>
           <a:prstGeom prst="rect">
@@ -3198,13 +3369,13 @@
       </p:sp>
       <p:sp>
         <p:nvSpPr>
-          <p:cNvPr id="61" name="Text 59"/>
-          <p:cNvSpPr/>
-          <p:nvPr/>
-        </p:nvSpPr>
-        <p:spPr>
-          <a:xfrm>
-            <a:off x="274320" y="5029200"/>
+          <p:cNvPr id="62" name="Text 60"/>
+          <p:cNvSpPr/>
+          <p:nvPr/>
+        </p:nvSpPr>
+        <p:spPr>
+          <a:xfrm>
+            <a:off x="274320" y="5623560"/>
             <a:ext cx="2560320" cy="438912"/>
           </a:xfrm>
           <a:prstGeom prst="rect">
@@ -3254,13 +3425,13 @@
       </p:sp>
       <p:sp>
         <p:nvSpPr>
-          <p:cNvPr id="62" name="Shape 60"/>
-          <p:cNvSpPr/>
-          <p:nvPr/>
-        </p:nvSpPr>
-        <p:spPr>
-          <a:xfrm>
-            <a:off x="2834640" y="5029200"/>
+          <p:cNvPr id="63" name="Shape 61"/>
+          <p:cNvSpPr/>
+          <p:nvPr/>
+        </p:nvSpPr>
+        <p:spPr>
+          <a:xfrm>
+            <a:off x="2834640" y="5623560"/>
             <a:ext cx="1207008" cy="438912"/>
           </a:xfrm>
           <a:prstGeom prst="rect">
@@ -3279,13 +3450,13 @@
       </p:sp>
       <p:sp>
         <p:nvSpPr>
-          <p:cNvPr id="63" name="Text 61"/>
-          <p:cNvSpPr/>
-          <p:nvPr/>
-        </p:nvSpPr>
-        <p:spPr>
-          <a:xfrm>
-            <a:off x="2834640" y="5029200"/>
+          <p:cNvPr id="64" name="Text 62"/>
+          <p:cNvSpPr/>
+          <p:nvPr/>
+        </p:nvSpPr>
+        <p:spPr>
+          <a:xfrm>
+            <a:off x="2834640" y="5623560"/>
             <a:ext cx="1207008" cy="438912"/>
           </a:xfrm>
           <a:prstGeom prst="rect">
@@ -3335,13 +3506,13 @@
       </p:sp>
       <p:sp>
         <p:nvSpPr>
-          <p:cNvPr id="64" name="Shape 62"/>
-          <p:cNvSpPr/>
-          <p:nvPr/>
-        </p:nvSpPr>
-        <p:spPr>
-          <a:xfrm>
-            <a:off x="4041648" y="5029200"/>
+          <p:cNvPr id="65" name="Shape 63"/>
+          <p:cNvSpPr/>
+          <p:nvPr/>
+        </p:nvSpPr>
+        <p:spPr>
+          <a:xfrm>
+            <a:off x="4041648" y="5623560"/>
             <a:ext cx="1207008" cy="438912"/>
           </a:xfrm>
           <a:prstGeom prst="rect">
@@ -3360,13 +3531,13 @@
       </p:sp>
       <p:sp>
         <p:nvSpPr>
-          <p:cNvPr id="65" name="Text 63"/>
-          <p:cNvSpPr/>
-          <p:nvPr/>
-        </p:nvSpPr>
-        <p:spPr>
-          <a:xfrm>
-            <a:off x="4041648" y="5029200"/>
+          <p:cNvPr id="66" name="Text 64"/>
+          <p:cNvSpPr/>
+          <p:nvPr/>
+        </p:nvSpPr>
+        <p:spPr>
+          <a:xfrm>
+            <a:off x="4041648" y="5623560"/>
             <a:ext cx="1207008" cy="438912"/>
           </a:xfrm>
           <a:prstGeom prst="rect">
@@ -3416,13 +3587,13 @@
       </p:sp>
       <p:sp>
         <p:nvSpPr>
-          <p:cNvPr id="66" name="Shape 64"/>
-          <p:cNvSpPr/>
-          <p:nvPr/>
-        </p:nvSpPr>
-        <p:spPr>
-          <a:xfrm>
-            <a:off x="5248656" y="5029200"/>
+          <p:cNvPr id="67" name="Shape 65"/>
+          <p:cNvSpPr/>
+          <p:nvPr/>
+        </p:nvSpPr>
+        <p:spPr>
+          <a:xfrm>
+            <a:off x="5248656" y="5623560"/>
             <a:ext cx="1207008" cy="438912"/>
           </a:xfrm>
           <a:prstGeom prst="rect">
@@ -3441,13 +3612,13 @@
       </p:sp>
       <p:sp>
         <p:nvSpPr>
-          <p:cNvPr id="67" name="Text 65"/>
-          <p:cNvSpPr/>
-          <p:nvPr/>
-        </p:nvSpPr>
-        <p:spPr>
-          <a:xfrm>
-            <a:off x="5248656" y="5029200"/>
+          <p:cNvPr id="68" name="Text 66"/>
+          <p:cNvSpPr/>
+          <p:nvPr/>
+        </p:nvSpPr>
+        <p:spPr>
+          <a:xfrm>
+            <a:off x="5248656" y="5623560"/>
             <a:ext cx="1207008" cy="438912"/>
           </a:xfrm>
           <a:prstGeom prst="rect">
@@ -3497,13 +3668,13 @@
       </p:sp>
       <p:sp>
         <p:nvSpPr>
-          <p:cNvPr id="68" name="Shape 66"/>
-          <p:cNvSpPr/>
-          <p:nvPr/>
-        </p:nvSpPr>
-        <p:spPr>
-          <a:xfrm>
-            <a:off x="6455664" y="5029200"/>
+          <p:cNvPr id="69" name="Shape 67"/>
+          <p:cNvSpPr/>
+          <p:nvPr/>
+        </p:nvSpPr>
+        <p:spPr>
+          <a:xfrm>
+            <a:off x="6455664" y="5623560"/>
             <a:ext cx="1207008" cy="438912"/>
           </a:xfrm>
           <a:prstGeom prst="rect">
@@ -3522,13 +3693,13 @@
       </p:sp>
       <p:sp>
         <p:nvSpPr>
-          <p:cNvPr id="69" name="Text 67"/>
-          <p:cNvSpPr/>
-          <p:nvPr/>
-        </p:nvSpPr>
-        <p:spPr>
-          <a:xfrm>
-            <a:off x="6455664" y="5029200"/>
+          <p:cNvPr id="70" name="Text 68"/>
+          <p:cNvSpPr/>
+          <p:nvPr/>
+        </p:nvSpPr>
+        <p:spPr>
+          <a:xfrm>
+            <a:off x="6455664" y="5623560"/>
             <a:ext cx="1207008" cy="438912"/>
           </a:xfrm>
           <a:prstGeom prst="rect">
@@ -3578,13 +3749,13 @@
       </p:sp>
       <p:sp>
         <p:nvSpPr>
-          <p:cNvPr id="70" name="Shape 68"/>
-          <p:cNvSpPr/>
-          <p:nvPr/>
-        </p:nvSpPr>
-        <p:spPr>
-          <a:xfrm>
-            <a:off x="7662672" y="5029200"/>
+          <p:cNvPr id="71" name="Shape 69"/>
+          <p:cNvSpPr/>
+          <p:nvPr/>
+        </p:nvSpPr>
+        <p:spPr>
+          <a:xfrm>
+            <a:off x="7662672" y="5623560"/>
             <a:ext cx="1207008" cy="438912"/>
           </a:xfrm>
           <a:prstGeom prst="rect">
@@ -3603,13 +3774,13 @@
       </p:sp>
       <p:sp>
         <p:nvSpPr>
-          <p:cNvPr id="71" name="Text 69"/>
-          <p:cNvSpPr/>
-          <p:nvPr/>
-        </p:nvSpPr>
-        <p:spPr>
-          <a:xfrm>
-            <a:off x="7662672" y="5029200"/>
+          <p:cNvPr id="72" name="Text 70"/>
+          <p:cNvSpPr/>
+          <p:nvPr/>
+        </p:nvSpPr>
+        <p:spPr>
+          <a:xfrm>
+            <a:off x="7662672" y="5623560"/>
             <a:ext cx="1207008" cy="438912"/>
           </a:xfrm>
           <a:prstGeom prst="rect">
@@ -3659,13 +3830,13 @@
       </p:sp>
       <p:sp>
         <p:nvSpPr>
-          <p:cNvPr id="72" name="Shape 70"/>
-          <p:cNvSpPr/>
-          <p:nvPr/>
-        </p:nvSpPr>
-        <p:spPr>
-          <a:xfrm>
-            <a:off x="8869680" y="5029200"/>
+          <p:cNvPr id="73" name="Shape 71"/>
+          <p:cNvSpPr/>
+          <p:nvPr/>
+        </p:nvSpPr>
+        <p:spPr>
+          <a:xfrm>
+            <a:off x="8869680" y="5623560"/>
             <a:ext cx="1207008" cy="438912"/>
           </a:xfrm>
           <a:prstGeom prst="rect">
@@ -3684,13 +3855,13 @@
       </p:sp>
       <p:sp>
         <p:nvSpPr>
-          <p:cNvPr id="73" name="Text 71"/>
-          <p:cNvSpPr/>
-          <p:nvPr/>
-        </p:nvSpPr>
-        <p:spPr>
-          <a:xfrm>
-            <a:off x="8869680" y="5029200"/>
+          <p:cNvPr id="74" name="Text 72"/>
+          <p:cNvSpPr/>
+          <p:nvPr/>
+        </p:nvSpPr>
+        <p:spPr>
+          <a:xfrm>
+            <a:off x="8869680" y="5623560"/>
             <a:ext cx="1207008" cy="438912"/>
           </a:xfrm>
           <a:prstGeom prst="rect">
@@ -3740,13 +3911,13 @@
       </p:sp>
       <p:sp>
         <p:nvSpPr>
-          <p:cNvPr id="74" name="Shape 72"/>
-          <p:cNvSpPr/>
-          <p:nvPr/>
-        </p:nvSpPr>
-        <p:spPr>
-          <a:xfrm>
-            <a:off x="10076688" y="5029200"/>
+          <p:cNvPr id="75" name="Shape 73"/>
+          <p:cNvSpPr/>
+          <p:nvPr/>
+        </p:nvSpPr>
+        <p:spPr>
+          <a:xfrm>
+            <a:off x="10076688" y="5623560"/>
             <a:ext cx="1207008" cy="438912"/>
           </a:xfrm>
           <a:prstGeom prst="rect">
@@ -3765,13 +3936,13 @@
       </p:sp>
       <p:sp>
         <p:nvSpPr>
-          <p:cNvPr id="75" name="Text 73"/>
-          <p:cNvSpPr/>
-          <p:nvPr/>
-        </p:nvSpPr>
-        <p:spPr>
-          <a:xfrm>
-            <a:off x="10076688" y="5029200"/>
+          <p:cNvPr id="76" name="Text 74"/>
+          <p:cNvSpPr/>
+          <p:nvPr/>
+        </p:nvSpPr>
+        <p:spPr>
+          <a:xfrm>
+            <a:off x="10076688" y="5623560"/>
             <a:ext cx="1207008" cy="438912"/>
           </a:xfrm>
           <a:prstGeom prst="rect">
@@ -3821,13 +3992,13 @@
       </p:sp>
       <p:sp>
         <p:nvSpPr>
-          <p:cNvPr id="76" name="Shape 74"/>
-          <p:cNvSpPr/>
-          <p:nvPr/>
-        </p:nvSpPr>
-        <p:spPr>
-          <a:xfrm>
-            <a:off x="11283696" y="5029200"/>
+          <p:cNvPr id="77" name="Shape 75"/>
+          <p:cNvSpPr/>
+          <p:nvPr/>
+        </p:nvSpPr>
+        <p:spPr>
+          <a:xfrm>
+            <a:off x="11283696" y="5623560"/>
             <a:ext cx="1207008" cy="438912"/>
           </a:xfrm>
           <a:prstGeom prst="rect">
@@ -3846,13 +4017,13 @@
       </p:sp>
       <p:sp>
         <p:nvSpPr>
-          <p:cNvPr id="77" name="Text 75"/>
-          <p:cNvSpPr/>
-          <p:nvPr/>
-        </p:nvSpPr>
-        <p:spPr>
-          <a:xfrm>
-            <a:off x="11283696" y="5029200"/>
+          <p:cNvPr id="78" name="Text 76"/>
+          <p:cNvSpPr/>
+          <p:nvPr/>
+        </p:nvSpPr>
+        <p:spPr>
+          <a:xfrm>
+            <a:off x="11283696" y="5623560"/>
             <a:ext cx="1207008" cy="438912"/>
           </a:xfrm>
           <a:prstGeom prst="rect">
@@ -3902,13 +4073,13 @@
       </p:sp>
       <p:sp>
         <p:nvSpPr>
-          <p:cNvPr id="78" name="Shape 76"/>
-          <p:cNvSpPr/>
-          <p:nvPr/>
-        </p:nvSpPr>
-        <p:spPr>
-          <a:xfrm>
-            <a:off x="274320" y="5468112"/>
+          <p:cNvPr id="79" name="Shape 77"/>
+          <p:cNvSpPr/>
+          <p:nvPr/>
+        </p:nvSpPr>
+        <p:spPr>
+          <a:xfrm>
+            <a:off x="274320" y="6062472"/>
             <a:ext cx="2560320" cy="347472"/>
           </a:xfrm>
           <a:prstGeom prst="rect">
@@ -3927,13 +4098,13 @@
       </p:sp>
       <p:sp>
         <p:nvSpPr>
-          <p:cNvPr id="79" name="Text 77"/>
-          <p:cNvSpPr/>
-          <p:nvPr/>
-        </p:nvSpPr>
-        <p:spPr>
-          <a:xfrm>
-            <a:off x="365760" y="5468112"/>
+          <p:cNvPr id="80" name="Text 78"/>
+          <p:cNvSpPr/>
+          <p:nvPr/>
+        </p:nvSpPr>
+        <p:spPr>
+          <a:xfrm>
+            <a:off x="365760" y="6062472"/>
             <a:ext cx="2377440" cy="347472"/>
           </a:xfrm>
           <a:prstGeom prst="rect">
@@ -3966,13 +4137,13 @@
       </p:sp>
       <p:sp>
         <p:nvSpPr>
-          <p:cNvPr id="80" name="Shape 78"/>
-          <p:cNvSpPr/>
-          <p:nvPr/>
-        </p:nvSpPr>
-        <p:spPr>
-          <a:xfrm>
-            <a:off x="2834640" y="5468112"/>
+          <p:cNvPr id="81" name="Shape 79"/>
+          <p:cNvSpPr/>
+          <p:nvPr/>
+        </p:nvSpPr>
+        <p:spPr>
+          <a:xfrm>
+            <a:off x="2834640" y="6062472"/>
             <a:ext cx="1207008" cy="347472"/>
           </a:xfrm>
           <a:prstGeom prst="rect">
@@ -3991,13 +4162,13 @@
       </p:sp>
       <p:sp>
         <p:nvSpPr>
-          <p:cNvPr id="81" name="Text 79"/>
-          <p:cNvSpPr/>
-          <p:nvPr/>
-        </p:nvSpPr>
-        <p:spPr>
-          <a:xfrm>
-            <a:off x="2834640" y="5468112"/>
+          <p:cNvPr id="82" name="Text 80"/>
+          <p:cNvSpPr/>
+          <p:nvPr/>
+        </p:nvSpPr>
+        <p:spPr>
+          <a:xfrm>
+            <a:off x="2834640" y="6062472"/>
             <a:ext cx="1207008" cy="347472"/>
           </a:xfrm>
           <a:prstGeom prst="rect">
@@ -4030,13 +4201,13 @@
       </p:sp>
       <p:sp>
         <p:nvSpPr>
-          <p:cNvPr id="82" name="Shape 80"/>
-          <p:cNvSpPr/>
-          <p:nvPr/>
-        </p:nvSpPr>
-        <p:spPr>
-          <a:xfrm>
-            <a:off x="4041648" y="5468112"/>
+          <p:cNvPr id="83" name="Shape 81"/>
+          <p:cNvSpPr/>
+          <p:nvPr/>
+        </p:nvSpPr>
+        <p:spPr>
+          <a:xfrm>
+            <a:off x="4041648" y="6062472"/>
             <a:ext cx="1207008" cy="347472"/>
           </a:xfrm>
           <a:prstGeom prst="rect">
@@ -4055,13 +4226,13 @@
       </p:sp>
       <p:sp>
         <p:nvSpPr>
-          <p:cNvPr id="83" name="Text 81"/>
-          <p:cNvSpPr/>
-          <p:nvPr/>
-        </p:nvSpPr>
-        <p:spPr>
-          <a:xfrm>
-            <a:off x="4041648" y="5468112"/>
+          <p:cNvPr id="84" name="Text 82"/>
+          <p:cNvSpPr/>
+          <p:nvPr/>
+        </p:nvSpPr>
+        <p:spPr>
+          <a:xfrm>
+            <a:off x="4041648" y="6062472"/>
             <a:ext cx="1207008" cy="347472"/>
           </a:xfrm>
           <a:prstGeom prst="rect">
@@ -4094,13 +4265,13 @@
       </p:sp>
       <p:sp>
         <p:nvSpPr>
-          <p:cNvPr id="84" name="Shape 82"/>
-          <p:cNvSpPr/>
-          <p:nvPr/>
-        </p:nvSpPr>
-        <p:spPr>
-          <a:xfrm>
-            <a:off x="5248656" y="5468112"/>
+          <p:cNvPr id="85" name="Shape 83"/>
+          <p:cNvSpPr/>
+          <p:nvPr/>
+        </p:nvSpPr>
+        <p:spPr>
+          <a:xfrm>
+            <a:off x="5248656" y="6062472"/>
             <a:ext cx="1207008" cy="347472"/>
           </a:xfrm>
           <a:prstGeom prst="rect">
@@ -4119,13 +4290,13 @@
       </p:sp>
       <p:sp>
         <p:nvSpPr>
-          <p:cNvPr id="85" name="Text 83"/>
-          <p:cNvSpPr/>
-          <p:nvPr/>
-        </p:nvSpPr>
-        <p:spPr>
-          <a:xfrm>
-            <a:off x="5248656" y="5468112"/>
+          <p:cNvPr id="86" name="Text 84"/>
+          <p:cNvSpPr/>
+          <p:nvPr/>
+        </p:nvSpPr>
+        <p:spPr>
+          <a:xfrm>
+            <a:off x="5248656" y="6062472"/>
             <a:ext cx="1207008" cy="347472"/>
           </a:xfrm>
           <a:prstGeom prst="rect">
@@ -4158,13 +4329,13 @@
       </p:sp>
       <p:sp>
         <p:nvSpPr>
-          <p:cNvPr id="86" name="Shape 84"/>
-          <p:cNvSpPr/>
-          <p:nvPr/>
-        </p:nvSpPr>
-        <p:spPr>
-          <a:xfrm>
-            <a:off x="6455664" y="5468112"/>
+          <p:cNvPr id="87" name="Shape 85"/>
+          <p:cNvSpPr/>
+          <p:nvPr/>
+        </p:nvSpPr>
+        <p:spPr>
+          <a:xfrm>
+            <a:off x="6455664" y="6062472"/>
             <a:ext cx="1207008" cy="347472"/>
           </a:xfrm>
           <a:prstGeom prst="rect">
@@ -4183,13 +4354,13 @@
       </p:sp>
       <p:sp>
         <p:nvSpPr>
-          <p:cNvPr id="87" name="Text 85"/>
-          <p:cNvSpPr/>
-          <p:nvPr/>
-        </p:nvSpPr>
-        <p:spPr>
-          <a:xfrm>
-            <a:off x="6455664" y="5468112"/>
+          <p:cNvPr id="88" name="Text 86"/>
+          <p:cNvSpPr/>
+          <p:nvPr/>
+        </p:nvSpPr>
+        <p:spPr>
+          <a:xfrm>
+            <a:off x="6455664" y="6062472"/>
             <a:ext cx="1207008" cy="347472"/>
           </a:xfrm>
           <a:prstGeom prst="rect">
@@ -4222,13 +4393,13 @@
       </p:sp>
       <p:sp>
         <p:nvSpPr>
-          <p:cNvPr id="88" name="Shape 86"/>
-          <p:cNvSpPr/>
-          <p:nvPr/>
-        </p:nvSpPr>
-        <p:spPr>
-          <a:xfrm>
-            <a:off x="7662672" y="5468112"/>
+          <p:cNvPr id="89" name="Shape 87"/>
+          <p:cNvSpPr/>
+          <p:nvPr/>
+        </p:nvSpPr>
+        <p:spPr>
+          <a:xfrm>
+            <a:off x="7662672" y="6062472"/>
             <a:ext cx="1207008" cy="347472"/>
           </a:xfrm>
           <a:prstGeom prst="rect">
@@ -4247,13 +4418,13 @@
       </p:sp>
       <p:sp>
         <p:nvSpPr>
-          <p:cNvPr id="89" name="Text 87"/>
-          <p:cNvSpPr/>
-          <p:nvPr/>
-        </p:nvSpPr>
-        <p:spPr>
-          <a:xfrm>
-            <a:off x="7662672" y="5468112"/>
+          <p:cNvPr id="90" name="Text 88"/>
+          <p:cNvSpPr/>
+          <p:nvPr/>
+        </p:nvSpPr>
+        <p:spPr>
+          <a:xfrm>
+            <a:off x="7662672" y="6062472"/>
             <a:ext cx="1207008" cy="347472"/>
           </a:xfrm>
           <a:prstGeom prst="rect">
@@ -4286,13 +4457,13 @@
       </p:sp>
       <p:sp>
         <p:nvSpPr>
-          <p:cNvPr id="90" name="Shape 88"/>
-          <p:cNvSpPr/>
-          <p:nvPr/>
-        </p:nvSpPr>
-        <p:spPr>
-          <a:xfrm>
-            <a:off x="8869680" y="5468112"/>
+          <p:cNvPr id="91" name="Shape 89"/>
+          <p:cNvSpPr/>
+          <p:nvPr/>
+        </p:nvSpPr>
+        <p:spPr>
+          <a:xfrm>
+            <a:off x="8869680" y="6062472"/>
             <a:ext cx="1207008" cy="347472"/>
           </a:xfrm>
           <a:prstGeom prst="rect">
@@ -4311,13 +4482,13 @@
       </p:sp>
       <p:sp>
         <p:nvSpPr>
-          <p:cNvPr id="91" name="Text 89"/>
-          <p:cNvSpPr/>
-          <p:nvPr/>
-        </p:nvSpPr>
-        <p:spPr>
-          <a:xfrm>
-            <a:off x="8869680" y="5468112"/>
+          <p:cNvPr id="92" name="Text 90"/>
+          <p:cNvSpPr/>
+          <p:nvPr/>
+        </p:nvSpPr>
+        <p:spPr>
+          <a:xfrm>
+            <a:off x="8869680" y="6062472"/>
             <a:ext cx="1207008" cy="347472"/>
           </a:xfrm>
           <a:prstGeom prst="rect">
@@ -4350,13 +4521,13 @@
       </p:sp>
       <p:sp>
         <p:nvSpPr>
-          <p:cNvPr id="92" name="Shape 90"/>
-          <p:cNvSpPr/>
-          <p:nvPr/>
-        </p:nvSpPr>
-        <p:spPr>
-          <a:xfrm>
-            <a:off x="10076688" y="5468112"/>
+          <p:cNvPr id="93" name="Shape 91"/>
+          <p:cNvSpPr/>
+          <p:nvPr/>
+        </p:nvSpPr>
+        <p:spPr>
+          <a:xfrm>
+            <a:off x="10076688" y="6062472"/>
             <a:ext cx="1207008" cy="347472"/>
           </a:xfrm>
           <a:prstGeom prst="rect">
@@ -4375,13 +4546,13 @@
       </p:sp>
       <p:sp>
         <p:nvSpPr>
-          <p:cNvPr id="93" name="Text 91"/>
-          <p:cNvSpPr/>
-          <p:nvPr/>
-        </p:nvSpPr>
-        <p:spPr>
-          <a:xfrm>
-            <a:off x="10076688" y="5468112"/>
+          <p:cNvPr id="94" name="Text 92"/>
+          <p:cNvSpPr/>
+          <p:nvPr/>
+        </p:nvSpPr>
+        <p:spPr>
+          <a:xfrm>
+            <a:off x="10076688" y="6062472"/>
             <a:ext cx="1207008" cy="347472"/>
           </a:xfrm>
           <a:prstGeom prst="rect">
@@ -4414,13 +4585,13 @@
       </p:sp>
       <p:sp>
         <p:nvSpPr>
-          <p:cNvPr id="94" name="Shape 92"/>
-          <p:cNvSpPr/>
-          <p:nvPr/>
-        </p:nvSpPr>
-        <p:spPr>
-          <a:xfrm>
-            <a:off x="11283696" y="5468112"/>
+          <p:cNvPr id="95" name="Shape 93"/>
+          <p:cNvSpPr/>
+          <p:nvPr/>
+        </p:nvSpPr>
+        <p:spPr>
+          <a:xfrm>
+            <a:off x="11283696" y="6062472"/>
             <a:ext cx="1207008" cy="347472"/>
           </a:xfrm>
           <a:prstGeom prst="rect">
@@ -4439,13 +4610,13 @@
       </p:sp>
       <p:sp>
         <p:nvSpPr>
-          <p:cNvPr id="95" name="Text 93"/>
-          <p:cNvSpPr/>
-          <p:nvPr/>
-        </p:nvSpPr>
-        <p:spPr>
-          <a:xfrm>
-            <a:off x="11283696" y="5468112"/>
+          <p:cNvPr id="96" name="Text 94"/>
+          <p:cNvSpPr/>
+          <p:nvPr/>
+        </p:nvSpPr>
+        <p:spPr>
+          <a:xfrm>
+            <a:off x="11283696" y="6062472"/>
             <a:ext cx="1207008" cy="347472"/>
           </a:xfrm>
           <a:prstGeom prst="rect">
@@ -4478,13 +4649,13 @@
       </p:sp>
       <p:sp>
         <p:nvSpPr>
-          <p:cNvPr id="96" name="Shape 94"/>
-          <p:cNvSpPr/>
-          <p:nvPr/>
-        </p:nvSpPr>
-        <p:spPr>
-          <a:xfrm>
-            <a:off x="274320" y="5815584"/>
+          <p:cNvPr id="97" name="Shape 95"/>
+          <p:cNvSpPr/>
+          <p:nvPr/>
+        </p:nvSpPr>
+        <p:spPr>
+          <a:xfrm>
+            <a:off x="274320" y="6409944"/>
             <a:ext cx="2560320" cy="347472"/>
           </a:xfrm>
           <a:prstGeom prst="rect">
@@ -4503,13 +4674,13 @@
       </p:sp>
       <p:sp>
         <p:nvSpPr>
-          <p:cNvPr id="97" name="Text 95"/>
-          <p:cNvSpPr/>
-          <p:nvPr/>
-        </p:nvSpPr>
-        <p:spPr>
-          <a:xfrm>
-            <a:off x="365760" y="5815584"/>
+          <p:cNvPr id="98" name="Text 96"/>
+          <p:cNvSpPr/>
+          <p:nvPr/>
+        </p:nvSpPr>
+        <p:spPr>
+          <a:xfrm>
+            <a:off x="365760" y="6409944"/>
             <a:ext cx="2377440" cy="347472"/>
           </a:xfrm>
           <a:prstGeom prst="rect">
@@ -4542,13 +4713,13 @@
       </p:sp>
       <p:sp>
         <p:nvSpPr>
-          <p:cNvPr id="98" name="Shape 96"/>
-          <p:cNvSpPr/>
-          <p:nvPr/>
-        </p:nvSpPr>
-        <p:spPr>
-          <a:xfrm>
-            <a:off x="2834640" y="5815584"/>
+          <p:cNvPr id="99" name="Shape 97"/>
+          <p:cNvSpPr/>
+          <p:nvPr/>
+        </p:nvSpPr>
+        <p:spPr>
+          <a:xfrm>
+            <a:off x="2834640" y="6409944"/>
             <a:ext cx="1207008" cy="347472"/>
           </a:xfrm>
           <a:prstGeom prst="rect">
@@ -4567,13 +4738,13 @@
       </p:sp>
       <p:sp>
         <p:nvSpPr>
-          <p:cNvPr id="99" name="Text 97"/>
-          <p:cNvSpPr/>
-          <p:nvPr/>
-        </p:nvSpPr>
-        <p:spPr>
-          <a:xfrm>
-            <a:off x="2834640" y="5815584"/>
+          <p:cNvPr id="100" name="Text 98"/>
+          <p:cNvSpPr/>
+          <p:nvPr/>
+        </p:nvSpPr>
+        <p:spPr>
+          <a:xfrm>
+            <a:off x="2834640" y="6409944"/>
             <a:ext cx="1207008" cy="347472"/>
           </a:xfrm>
           <a:prstGeom prst="rect">
@@ -4606,13 +4777,13 @@
       </p:sp>
       <p:sp>
         <p:nvSpPr>
-          <p:cNvPr id="100" name="Shape 98"/>
-          <p:cNvSpPr/>
-          <p:nvPr/>
-        </p:nvSpPr>
-        <p:spPr>
-          <a:xfrm>
-            <a:off x="4041648" y="5815584"/>
+          <p:cNvPr id="101" name="Shape 99"/>
+          <p:cNvSpPr/>
+          <p:nvPr/>
+        </p:nvSpPr>
+        <p:spPr>
+          <a:xfrm>
+            <a:off x="4041648" y="6409944"/>
             <a:ext cx="1207008" cy="347472"/>
           </a:xfrm>
           <a:prstGeom prst="rect">
@@ -4631,13 +4802,13 @@
       </p:sp>
       <p:sp>
         <p:nvSpPr>
-          <p:cNvPr id="101" name="Text 99"/>
-          <p:cNvSpPr/>
-          <p:nvPr/>
-        </p:nvSpPr>
-        <p:spPr>
-          <a:xfrm>
-            <a:off x="4041648" y="5815584"/>
+          <p:cNvPr id="102" name="Text 100"/>
+          <p:cNvSpPr/>
+          <p:nvPr/>
+        </p:nvSpPr>
+        <p:spPr>
+          <a:xfrm>
+            <a:off x="4041648" y="6409944"/>
             <a:ext cx="1207008" cy="347472"/>
           </a:xfrm>
           <a:prstGeom prst="rect">
@@ -4670,13 +4841,13 @@
       </p:sp>
       <p:sp>
         <p:nvSpPr>
-          <p:cNvPr id="102" name="Shape 100"/>
-          <p:cNvSpPr/>
-          <p:nvPr/>
-        </p:nvSpPr>
-        <p:spPr>
-          <a:xfrm>
-            <a:off x="5248656" y="5815584"/>
+          <p:cNvPr id="103" name="Shape 101"/>
+          <p:cNvSpPr/>
+          <p:nvPr/>
+        </p:nvSpPr>
+        <p:spPr>
+          <a:xfrm>
+            <a:off x="5248656" y="6409944"/>
             <a:ext cx="1207008" cy="347472"/>
           </a:xfrm>
           <a:prstGeom prst="rect">
@@ -4695,13 +4866,13 @@
       </p:sp>
       <p:sp>
         <p:nvSpPr>
-          <p:cNvPr id="103" name="Text 101"/>
-          <p:cNvSpPr/>
-          <p:nvPr/>
-        </p:nvSpPr>
-        <p:spPr>
-          <a:xfrm>
-            <a:off x="5248656" y="5815584"/>
+          <p:cNvPr id="104" name="Text 102"/>
+          <p:cNvSpPr/>
+          <p:nvPr/>
+        </p:nvSpPr>
+        <p:spPr>
+          <a:xfrm>
+            <a:off x="5248656" y="6409944"/>
             <a:ext cx="1207008" cy="347472"/>
           </a:xfrm>
           <a:prstGeom prst="rect">
@@ -4734,13 +4905,13 @@
       </p:sp>
       <p:sp>
         <p:nvSpPr>
-          <p:cNvPr id="104" name="Shape 102"/>
-          <p:cNvSpPr/>
-          <p:nvPr/>
-        </p:nvSpPr>
-        <p:spPr>
-          <a:xfrm>
-            <a:off x="6455664" y="5815584"/>
+          <p:cNvPr id="105" name="Shape 103"/>
+          <p:cNvSpPr/>
+          <p:nvPr/>
+        </p:nvSpPr>
+        <p:spPr>
+          <a:xfrm>
+            <a:off x="6455664" y="6409944"/>
             <a:ext cx="1207008" cy="347472"/>
           </a:xfrm>
           <a:prstGeom prst="rect">
@@ -4759,13 +4930,13 @@
       </p:sp>
       <p:sp>
         <p:nvSpPr>
-          <p:cNvPr id="105" name="Text 103"/>
-          <p:cNvSpPr/>
-          <p:nvPr/>
-        </p:nvSpPr>
-        <p:spPr>
-          <a:xfrm>
-            <a:off x="6455664" y="5815584"/>
+          <p:cNvPr id="106" name="Text 104"/>
+          <p:cNvSpPr/>
+          <p:nvPr/>
+        </p:nvSpPr>
+        <p:spPr>
+          <a:xfrm>
+            <a:off x="6455664" y="6409944"/>
             <a:ext cx="1207008" cy="347472"/>
           </a:xfrm>
           <a:prstGeom prst="rect">
@@ -4798,13 +4969,13 @@
       </p:sp>
       <p:sp>
         <p:nvSpPr>
-          <p:cNvPr id="106" name="Shape 104"/>
-          <p:cNvSpPr/>
-          <p:nvPr/>
-        </p:nvSpPr>
-        <p:spPr>
-          <a:xfrm>
-            <a:off x="7662672" y="5815584"/>
+          <p:cNvPr id="107" name="Shape 105"/>
+          <p:cNvSpPr/>
+          <p:nvPr/>
+        </p:nvSpPr>
+        <p:spPr>
+          <a:xfrm>
+            <a:off x="7662672" y="6409944"/>
             <a:ext cx="1207008" cy="347472"/>
           </a:xfrm>
           <a:prstGeom prst="rect">
@@ -4823,13 +4994,13 @@
       </p:sp>
       <p:sp>
         <p:nvSpPr>
-          <p:cNvPr id="107" name="Text 105"/>
-          <p:cNvSpPr/>
-          <p:nvPr/>
-        </p:nvSpPr>
-        <p:spPr>
-          <a:xfrm>
-            <a:off x="7662672" y="5815584"/>
+          <p:cNvPr id="108" name="Text 106"/>
+          <p:cNvSpPr/>
+          <p:nvPr/>
+        </p:nvSpPr>
+        <p:spPr>
+          <a:xfrm>
+            <a:off x="7662672" y="6409944"/>
             <a:ext cx="1207008" cy="347472"/>
           </a:xfrm>
           <a:prstGeom prst="rect">
@@ -4862,13 +5033,13 @@
       </p:sp>
       <p:sp>
         <p:nvSpPr>
-          <p:cNvPr id="108" name="Shape 106"/>
-          <p:cNvSpPr/>
-          <p:nvPr/>
-        </p:nvSpPr>
-        <p:spPr>
-          <a:xfrm>
-            <a:off x="8869680" y="5815584"/>
+          <p:cNvPr id="109" name="Shape 107"/>
+          <p:cNvSpPr/>
+          <p:nvPr/>
+        </p:nvSpPr>
+        <p:spPr>
+          <a:xfrm>
+            <a:off x="8869680" y="6409944"/>
             <a:ext cx="1207008" cy="347472"/>
           </a:xfrm>
           <a:prstGeom prst="rect">
@@ -4887,13 +5058,13 @@
       </p:sp>
       <p:sp>
         <p:nvSpPr>
-          <p:cNvPr id="109" name="Text 107"/>
-          <p:cNvSpPr/>
-          <p:nvPr/>
-        </p:nvSpPr>
-        <p:spPr>
-          <a:xfrm>
-            <a:off x="8869680" y="5815584"/>
+          <p:cNvPr id="110" name="Text 108"/>
+          <p:cNvSpPr/>
+          <p:nvPr/>
+        </p:nvSpPr>
+        <p:spPr>
+          <a:xfrm>
+            <a:off x="8869680" y="6409944"/>
             <a:ext cx="1207008" cy="347472"/>
           </a:xfrm>
           <a:prstGeom prst="rect">
@@ -4926,13 +5097,13 @@
       </p:sp>
       <p:sp>
         <p:nvSpPr>
-          <p:cNvPr id="110" name="Shape 108"/>
-          <p:cNvSpPr/>
-          <p:nvPr/>
-        </p:nvSpPr>
-        <p:spPr>
-          <a:xfrm>
-            <a:off x="10076688" y="5815584"/>
+          <p:cNvPr id="111" name="Shape 109"/>
+          <p:cNvSpPr/>
+          <p:nvPr/>
+        </p:nvSpPr>
+        <p:spPr>
+          <a:xfrm>
+            <a:off x="10076688" y="6409944"/>
             <a:ext cx="1207008" cy="347472"/>
           </a:xfrm>
           <a:prstGeom prst="rect">
@@ -4951,13 +5122,13 @@
       </p:sp>
       <p:sp>
         <p:nvSpPr>
-          <p:cNvPr id="111" name="Text 109"/>
-          <p:cNvSpPr/>
-          <p:nvPr/>
-        </p:nvSpPr>
-        <p:spPr>
-          <a:xfrm>
-            <a:off x="10076688" y="5815584"/>
+          <p:cNvPr id="112" name="Text 110"/>
+          <p:cNvSpPr/>
+          <p:nvPr/>
+        </p:nvSpPr>
+        <p:spPr>
+          <a:xfrm>
+            <a:off x="10076688" y="6409944"/>
             <a:ext cx="1207008" cy="347472"/>
           </a:xfrm>
           <a:prstGeom prst="rect">
@@ -4990,13 +5161,13 @@
       </p:sp>
       <p:sp>
         <p:nvSpPr>
-          <p:cNvPr id="112" name="Shape 110"/>
-          <p:cNvSpPr/>
-          <p:nvPr/>
-        </p:nvSpPr>
-        <p:spPr>
-          <a:xfrm>
-            <a:off x="11283696" y="5815584"/>
+          <p:cNvPr id="113" name="Shape 111"/>
+          <p:cNvSpPr/>
+          <p:nvPr/>
+        </p:nvSpPr>
+        <p:spPr>
+          <a:xfrm>
+            <a:off x="11283696" y="6409944"/>
             <a:ext cx="1207008" cy="347472"/>
           </a:xfrm>
           <a:prstGeom prst="rect">
@@ -5015,13 +5186,13 @@
       </p:sp>
       <p:sp>
         <p:nvSpPr>
-          <p:cNvPr id="113" name="Text 111"/>
-          <p:cNvSpPr/>
-          <p:nvPr/>
-        </p:nvSpPr>
-        <p:spPr>
-          <a:xfrm>
-            <a:off x="11283696" y="5815584"/>
+          <p:cNvPr id="114" name="Text 112"/>
+          <p:cNvSpPr/>
+          <p:nvPr/>
+        </p:nvSpPr>
+        <p:spPr>
+          <a:xfrm>
+            <a:off x="11283696" y="6409944"/>
             <a:ext cx="1207008" cy="347472"/>
           </a:xfrm>
           <a:prstGeom prst="rect">
@@ -5054,13 +5225,13 @@
       </p:sp>
       <p:sp>
         <p:nvSpPr>
-          <p:cNvPr id="114" name="Shape 112"/>
-          <p:cNvSpPr/>
-          <p:nvPr/>
-        </p:nvSpPr>
-        <p:spPr>
-          <a:xfrm>
-            <a:off x="274320" y="6163056"/>
+          <p:cNvPr id="115" name="Shape 113"/>
+          <p:cNvSpPr/>
+          <p:nvPr/>
+        </p:nvSpPr>
+        <p:spPr>
+          <a:xfrm>
+            <a:off x="274320" y="6757416"/>
             <a:ext cx="2560320" cy="347472"/>
           </a:xfrm>
           <a:prstGeom prst="rect">
@@ -5079,13 +5250,13 @@
       </p:sp>
       <p:sp>
         <p:nvSpPr>
-          <p:cNvPr id="115" name="Text 113"/>
-          <p:cNvSpPr/>
-          <p:nvPr/>
-        </p:nvSpPr>
-        <p:spPr>
-          <a:xfrm>
-            <a:off x="365760" y="6163056"/>
+          <p:cNvPr id="116" name="Text 114"/>
+          <p:cNvSpPr/>
+          <p:nvPr/>
+        </p:nvSpPr>
+        <p:spPr>
+          <a:xfrm>
+            <a:off x="365760" y="6757416"/>
             <a:ext cx="2377440" cy="347472"/>
           </a:xfrm>
           <a:prstGeom prst="rect">
@@ -5118,13 +5289,13 @@
       </p:sp>
       <p:sp>
         <p:nvSpPr>
-          <p:cNvPr id="116" name="Shape 114"/>
-          <p:cNvSpPr/>
-          <p:nvPr/>
-        </p:nvSpPr>
-        <p:spPr>
-          <a:xfrm>
-            <a:off x="2834640" y="6163056"/>
+          <p:cNvPr id="117" name="Shape 115"/>
+          <p:cNvSpPr/>
+          <p:nvPr/>
+        </p:nvSpPr>
+        <p:spPr>
+          <a:xfrm>
+            <a:off x="2834640" y="6757416"/>
             <a:ext cx="1207008" cy="347472"/>
           </a:xfrm>
           <a:prstGeom prst="rect">
@@ -5143,13 +5314,13 @@
       </p:sp>
       <p:sp>
         <p:nvSpPr>
-          <p:cNvPr id="117" name="Text 115"/>
-          <p:cNvSpPr/>
-          <p:nvPr/>
-        </p:nvSpPr>
-        <p:spPr>
-          <a:xfrm>
-            <a:off x="2834640" y="6163056"/>
+          <p:cNvPr id="118" name="Text 116"/>
+          <p:cNvSpPr/>
+          <p:nvPr/>
+        </p:nvSpPr>
+        <p:spPr>
+          <a:xfrm>
+            <a:off x="2834640" y="6757416"/>
             <a:ext cx="1207008" cy="347472"/>
           </a:xfrm>
           <a:prstGeom prst="rect">
@@ -5182,13 +5353,13 @@
       </p:sp>
       <p:sp>
         <p:nvSpPr>
-          <p:cNvPr id="118" name="Shape 116"/>
-          <p:cNvSpPr/>
-          <p:nvPr/>
-        </p:nvSpPr>
-        <p:spPr>
-          <a:xfrm>
-            <a:off x="4041648" y="6163056"/>
+          <p:cNvPr id="119" name="Shape 117"/>
+          <p:cNvSpPr/>
+          <p:nvPr/>
+        </p:nvSpPr>
+        <p:spPr>
+          <a:xfrm>
+            <a:off x="4041648" y="6757416"/>
             <a:ext cx="1207008" cy="347472"/>
           </a:xfrm>
           <a:prstGeom prst="rect">
@@ -5207,13 +5378,13 @@
       </p:sp>
       <p:sp>
         <p:nvSpPr>
-          <p:cNvPr id="119" name="Text 117"/>
-          <p:cNvSpPr/>
-          <p:nvPr/>
-        </p:nvSpPr>
-        <p:spPr>
-          <a:xfrm>
-            <a:off x="4041648" y="6163056"/>
+          <p:cNvPr id="120" name="Text 118"/>
+          <p:cNvSpPr/>
+          <p:nvPr/>
+        </p:nvSpPr>
+        <p:spPr>
+          <a:xfrm>
+            <a:off x="4041648" y="6757416"/>
             <a:ext cx="1207008" cy="347472"/>
           </a:xfrm>
           <a:prstGeom prst="rect">
@@ -5246,13 +5417,13 @@
       </p:sp>
       <p:sp>
         <p:nvSpPr>
-          <p:cNvPr id="120" name="Shape 118"/>
-          <p:cNvSpPr/>
-          <p:nvPr/>
-        </p:nvSpPr>
-        <p:spPr>
-          <a:xfrm>
-            <a:off x="5248656" y="6163056"/>
+          <p:cNvPr id="121" name="Shape 119"/>
+          <p:cNvSpPr/>
+          <p:nvPr/>
+        </p:nvSpPr>
+        <p:spPr>
+          <a:xfrm>
+            <a:off x="5248656" y="6757416"/>
             <a:ext cx="1207008" cy="347472"/>
           </a:xfrm>
           <a:prstGeom prst="rect">
@@ -5271,13 +5442,13 @@
       </p:sp>
       <p:sp>
         <p:nvSpPr>
-          <p:cNvPr id="121" name="Text 119"/>
-          <p:cNvSpPr/>
-          <p:nvPr/>
-        </p:nvSpPr>
-        <p:spPr>
-          <a:xfrm>
-            <a:off x="5248656" y="6163056"/>
+          <p:cNvPr id="122" name="Text 120"/>
+          <p:cNvSpPr/>
+          <p:nvPr/>
+        </p:nvSpPr>
+        <p:spPr>
+          <a:xfrm>
+            <a:off x="5248656" y="6757416"/>
             <a:ext cx="1207008" cy="347472"/>
           </a:xfrm>
           <a:prstGeom prst="rect">
@@ -5310,13 +5481,13 @@
       </p:sp>
       <p:sp>
         <p:nvSpPr>
-          <p:cNvPr id="122" name="Shape 120"/>
-          <p:cNvSpPr/>
-          <p:nvPr/>
-        </p:nvSpPr>
-        <p:spPr>
-          <a:xfrm>
-            <a:off x="6455664" y="6163056"/>
+          <p:cNvPr id="123" name="Shape 121"/>
+          <p:cNvSpPr/>
+          <p:nvPr/>
+        </p:nvSpPr>
+        <p:spPr>
+          <a:xfrm>
+            <a:off x="6455664" y="6757416"/>
             <a:ext cx="1207008" cy="347472"/>
           </a:xfrm>
           <a:prstGeom prst="rect">
@@ -5335,13 +5506,13 @@
       </p:sp>
       <p:sp>
         <p:nvSpPr>
-          <p:cNvPr id="123" name="Text 121"/>
-          <p:cNvSpPr/>
-          <p:nvPr/>
-        </p:nvSpPr>
-        <p:spPr>
-          <a:xfrm>
-            <a:off x="6455664" y="6163056"/>
+          <p:cNvPr id="124" name="Text 122"/>
+          <p:cNvSpPr/>
+          <p:nvPr/>
+        </p:nvSpPr>
+        <p:spPr>
+          <a:xfrm>
+            <a:off x="6455664" y="6757416"/>
             <a:ext cx="1207008" cy="347472"/>
           </a:xfrm>
           <a:prstGeom prst="rect">
@@ -5374,13 +5545,13 @@
       </p:sp>
       <p:sp>
         <p:nvSpPr>
-          <p:cNvPr id="124" name="Shape 122"/>
-          <p:cNvSpPr/>
-          <p:nvPr/>
-        </p:nvSpPr>
-        <p:spPr>
-          <a:xfrm>
-            <a:off x="7662672" y="6163056"/>
+          <p:cNvPr id="125" name="Shape 123"/>
+          <p:cNvSpPr/>
+          <p:nvPr/>
+        </p:nvSpPr>
+        <p:spPr>
+          <a:xfrm>
+            <a:off x="7662672" y="6757416"/>
             <a:ext cx="1207008" cy="347472"/>
           </a:xfrm>
           <a:prstGeom prst="rect">
@@ -5399,13 +5570,13 @@
       </p:sp>
       <p:sp>
         <p:nvSpPr>
-          <p:cNvPr id="125" name="Text 123"/>
-          <p:cNvSpPr/>
-          <p:nvPr/>
-        </p:nvSpPr>
-        <p:spPr>
-          <a:xfrm>
-            <a:off x="7662672" y="6163056"/>
+          <p:cNvPr id="126" name="Text 124"/>
+          <p:cNvSpPr/>
+          <p:nvPr/>
+        </p:nvSpPr>
+        <p:spPr>
+          <a:xfrm>
+            <a:off x="7662672" y="6757416"/>
             <a:ext cx="1207008" cy="347472"/>
           </a:xfrm>
           <a:prstGeom prst="rect">
@@ -5438,13 +5609,13 @@
       </p:sp>
       <p:sp>
         <p:nvSpPr>
-          <p:cNvPr id="126" name="Shape 124"/>
-          <p:cNvSpPr/>
-          <p:nvPr/>
-        </p:nvSpPr>
-        <p:spPr>
-          <a:xfrm>
-            <a:off x="8869680" y="6163056"/>
+          <p:cNvPr id="127" name="Shape 125"/>
+          <p:cNvSpPr/>
+          <p:nvPr/>
+        </p:nvSpPr>
+        <p:spPr>
+          <a:xfrm>
+            <a:off x="8869680" y="6757416"/>
             <a:ext cx="1207008" cy="347472"/>
           </a:xfrm>
           <a:prstGeom prst="rect">
@@ -5463,13 +5634,13 @@
       </p:sp>
       <p:sp>
         <p:nvSpPr>
-          <p:cNvPr id="127" name="Text 125"/>
-          <p:cNvSpPr/>
-          <p:nvPr/>
-        </p:nvSpPr>
-        <p:spPr>
-          <a:xfrm>
-            <a:off x="8869680" y="6163056"/>
+          <p:cNvPr id="128" name="Text 126"/>
+          <p:cNvSpPr/>
+          <p:nvPr/>
+        </p:nvSpPr>
+        <p:spPr>
+          <a:xfrm>
+            <a:off x="8869680" y="6757416"/>
             <a:ext cx="1207008" cy="347472"/>
           </a:xfrm>
           <a:prstGeom prst="rect">
@@ -5502,13 +5673,13 @@
       </p:sp>
       <p:sp>
         <p:nvSpPr>
-          <p:cNvPr id="128" name="Shape 126"/>
-          <p:cNvSpPr/>
-          <p:nvPr/>
-        </p:nvSpPr>
-        <p:spPr>
-          <a:xfrm>
-            <a:off x="10076688" y="6163056"/>
+          <p:cNvPr id="129" name="Shape 127"/>
+          <p:cNvSpPr/>
+          <p:nvPr/>
+        </p:nvSpPr>
+        <p:spPr>
+          <a:xfrm>
+            <a:off x="10076688" y="6757416"/>
             <a:ext cx="1207008" cy="347472"/>
           </a:xfrm>
           <a:prstGeom prst="rect">
@@ -5527,13 +5698,13 @@
       </p:sp>
       <p:sp>
         <p:nvSpPr>
-          <p:cNvPr id="129" name="Text 127"/>
-          <p:cNvSpPr/>
-          <p:nvPr/>
-        </p:nvSpPr>
-        <p:spPr>
-          <a:xfrm>
-            <a:off x="10076688" y="6163056"/>
+          <p:cNvPr id="130" name="Text 128"/>
+          <p:cNvSpPr/>
+          <p:nvPr/>
+        </p:nvSpPr>
+        <p:spPr>
+          <a:xfrm>
+            <a:off x="10076688" y="6757416"/>
             <a:ext cx="1207008" cy="347472"/>
           </a:xfrm>
           <a:prstGeom prst="rect">
@@ -5566,13 +5737,13 @@
       </p:sp>
       <p:sp>
         <p:nvSpPr>
-          <p:cNvPr id="130" name="Shape 128"/>
-          <p:cNvSpPr/>
-          <p:nvPr/>
-        </p:nvSpPr>
-        <p:spPr>
-          <a:xfrm>
-            <a:off x="11283696" y="6163056"/>
+          <p:cNvPr id="131" name="Shape 129"/>
+          <p:cNvSpPr/>
+          <p:nvPr/>
+        </p:nvSpPr>
+        <p:spPr>
+          <a:xfrm>
+            <a:off x="11283696" y="6757416"/>
             <a:ext cx="1207008" cy="347472"/>
           </a:xfrm>
           <a:prstGeom prst="rect">
@@ -5591,13 +5762,13 @@
       </p:sp>
       <p:sp>
         <p:nvSpPr>
-          <p:cNvPr id="131" name="Text 129"/>
-          <p:cNvSpPr/>
-          <p:nvPr/>
-        </p:nvSpPr>
-        <p:spPr>
-          <a:xfrm>
-            <a:off x="11283696" y="6163056"/>
+          <p:cNvPr id="132" name="Text 130"/>
+          <p:cNvSpPr/>
+          <p:nvPr/>
+        </p:nvSpPr>
+        <p:spPr>
+          <a:xfrm>
+            <a:off x="11283696" y="6757416"/>
             <a:ext cx="1207008" cy="347472"/>
           </a:xfrm>
           <a:prstGeom prst="rect">
@@ -5630,13 +5801,13 @@
       </p:sp>
       <p:sp>
         <p:nvSpPr>
-          <p:cNvPr id="132" name="Shape 130"/>
-          <p:cNvSpPr/>
-          <p:nvPr/>
-        </p:nvSpPr>
-        <p:spPr>
-          <a:xfrm>
-            <a:off x="274320" y="6510528"/>
+          <p:cNvPr id="133" name="Shape 131"/>
+          <p:cNvSpPr/>
+          <p:nvPr/>
+        </p:nvSpPr>
+        <p:spPr>
+          <a:xfrm>
+            <a:off x="274320" y="7104888"/>
             <a:ext cx="2560320" cy="347472"/>
           </a:xfrm>
           <a:prstGeom prst="rect">
@@ -5655,13 +5826,13 @@
       </p:sp>
       <p:sp>
         <p:nvSpPr>
-          <p:cNvPr id="133" name="Text 131"/>
-          <p:cNvSpPr/>
-          <p:nvPr/>
-        </p:nvSpPr>
-        <p:spPr>
-          <a:xfrm>
-            <a:off x="365760" y="6510528"/>
+          <p:cNvPr id="134" name="Text 132"/>
+          <p:cNvSpPr/>
+          <p:nvPr/>
+        </p:nvSpPr>
+        <p:spPr>
+          <a:xfrm>
+            <a:off x="365760" y="7104888"/>
             <a:ext cx="2377440" cy="347472"/>
           </a:xfrm>
           <a:prstGeom prst="rect">
@@ -5694,13 +5865,13 @@
       </p:sp>
       <p:sp>
         <p:nvSpPr>
-          <p:cNvPr id="134" name="Shape 132"/>
-          <p:cNvSpPr/>
-          <p:nvPr/>
-        </p:nvSpPr>
-        <p:spPr>
-          <a:xfrm>
-            <a:off x="2834640" y="6510528"/>
+          <p:cNvPr id="135" name="Shape 133"/>
+          <p:cNvSpPr/>
+          <p:nvPr/>
+        </p:nvSpPr>
+        <p:spPr>
+          <a:xfrm>
+            <a:off x="2834640" y="7104888"/>
             <a:ext cx="1207008" cy="347472"/>
           </a:xfrm>
           <a:prstGeom prst="rect">
@@ -5719,13 +5890,13 @@
       </p:sp>
       <p:sp>
         <p:nvSpPr>
-          <p:cNvPr id="135" name="Text 133"/>
-          <p:cNvSpPr/>
-          <p:nvPr/>
-        </p:nvSpPr>
-        <p:spPr>
-          <a:xfrm>
-            <a:off x="2834640" y="6510528"/>
+          <p:cNvPr id="136" name="Text 134"/>
+          <p:cNvSpPr/>
+          <p:nvPr/>
+        </p:nvSpPr>
+        <p:spPr>
+          <a:xfrm>
+            <a:off x="2834640" y="7104888"/>
             <a:ext cx="1207008" cy="347472"/>
           </a:xfrm>
           <a:prstGeom prst="rect">
@@ -5758,13 +5929,13 @@
       </p:sp>
       <p:sp>
         <p:nvSpPr>
-          <p:cNvPr id="136" name="Shape 134"/>
-          <p:cNvSpPr/>
-          <p:nvPr/>
-        </p:nvSpPr>
-        <p:spPr>
-          <a:xfrm>
-            <a:off x="4041648" y="6510528"/>
+          <p:cNvPr id="137" name="Shape 135"/>
+          <p:cNvSpPr/>
+          <p:nvPr/>
+        </p:nvSpPr>
+        <p:spPr>
+          <a:xfrm>
+            <a:off x="4041648" y="7104888"/>
             <a:ext cx="1207008" cy="347472"/>
           </a:xfrm>
           <a:prstGeom prst="rect">
@@ -5783,13 +5954,13 @@
       </p:sp>
       <p:sp>
         <p:nvSpPr>
-          <p:cNvPr id="137" name="Text 135"/>
-          <p:cNvSpPr/>
-          <p:nvPr/>
-        </p:nvSpPr>
-        <p:spPr>
-          <a:xfrm>
-            <a:off x="4041648" y="6510528"/>
+          <p:cNvPr id="138" name="Text 136"/>
+          <p:cNvSpPr/>
+          <p:nvPr/>
+        </p:nvSpPr>
+        <p:spPr>
+          <a:xfrm>
+            <a:off x="4041648" y="7104888"/>
             <a:ext cx="1207008" cy="347472"/>
           </a:xfrm>
           <a:prstGeom prst="rect">
@@ -5822,13 +5993,13 @@
       </p:sp>
       <p:sp>
         <p:nvSpPr>
-          <p:cNvPr id="138" name="Shape 136"/>
-          <p:cNvSpPr/>
-          <p:nvPr/>
-        </p:nvSpPr>
-        <p:spPr>
-          <a:xfrm>
-            <a:off x="5248656" y="6510528"/>
+          <p:cNvPr id="139" name="Shape 137"/>
+          <p:cNvSpPr/>
+          <p:nvPr/>
+        </p:nvSpPr>
+        <p:spPr>
+          <a:xfrm>
+            <a:off x="5248656" y="7104888"/>
             <a:ext cx="1207008" cy="347472"/>
           </a:xfrm>
           <a:prstGeom prst="rect">
@@ -5847,13 +6018,13 @@
       </p:sp>
       <p:sp>
         <p:nvSpPr>
-          <p:cNvPr id="139" name="Text 137"/>
-          <p:cNvSpPr/>
-          <p:nvPr/>
-        </p:nvSpPr>
-        <p:spPr>
-          <a:xfrm>
-            <a:off x="5248656" y="6510528"/>
+          <p:cNvPr id="140" name="Text 138"/>
+          <p:cNvSpPr/>
+          <p:nvPr/>
+        </p:nvSpPr>
+        <p:spPr>
+          <a:xfrm>
+            <a:off x="5248656" y="7104888"/>
             <a:ext cx="1207008" cy="347472"/>
           </a:xfrm>
           <a:prstGeom prst="rect">
@@ -5886,13 +6057,13 @@
       </p:sp>
       <p:sp>
         <p:nvSpPr>
-          <p:cNvPr id="140" name="Shape 138"/>
-          <p:cNvSpPr/>
-          <p:nvPr/>
-        </p:nvSpPr>
-        <p:spPr>
-          <a:xfrm>
-            <a:off x="6455664" y="6510528"/>
+          <p:cNvPr id="141" name="Shape 139"/>
+          <p:cNvSpPr/>
+          <p:nvPr/>
+        </p:nvSpPr>
+        <p:spPr>
+          <a:xfrm>
+            <a:off x="6455664" y="7104888"/>
             <a:ext cx="1207008" cy="347472"/>
           </a:xfrm>
           <a:prstGeom prst="rect">
@@ -5911,13 +6082,13 @@
       </p:sp>
       <p:sp>
         <p:nvSpPr>
-          <p:cNvPr id="141" name="Text 139"/>
-          <p:cNvSpPr/>
-          <p:nvPr/>
-        </p:nvSpPr>
-        <p:spPr>
-          <a:xfrm>
-            <a:off x="6455664" y="6510528"/>
+          <p:cNvPr id="142" name="Text 140"/>
+          <p:cNvSpPr/>
+          <p:nvPr/>
+        </p:nvSpPr>
+        <p:spPr>
+          <a:xfrm>
+            <a:off x="6455664" y="7104888"/>
             <a:ext cx="1207008" cy="347472"/>
           </a:xfrm>
           <a:prstGeom prst="rect">
@@ -5950,13 +6121,13 @@
       </p:sp>
       <p:sp>
         <p:nvSpPr>
-          <p:cNvPr id="142" name="Shape 140"/>
-          <p:cNvSpPr/>
-          <p:nvPr/>
-        </p:nvSpPr>
-        <p:spPr>
-          <a:xfrm>
-            <a:off x="7662672" y="6510528"/>
+          <p:cNvPr id="143" name="Shape 141"/>
+          <p:cNvSpPr/>
+          <p:nvPr/>
+        </p:nvSpPr>
+        <p:spPr>
+          <a:xfrm>
+            <a:off x="7662672" y="7104888"/>
             <a:ext cx="1207008" cy="347472"/>
           </a:xfrm>
           <a:prstGeom prst="rect">
@@ -5975,13 +6146,13 @@
       </p:sp>
       <p:sp>
         <p:nvSpPr>
-          <p:cNvPr id="143" name="Text 141"/>
-          <p:cNvSpPr/>
-          <p:nvPr/>
-        </p:nvSpPr>
-        <p:spPr>
-          <a:xfrm>
-            <a:off x="7662672" y="6510528"/>
+          <p:cNvPr id="144" name="Text 142"/>
+          <p:cNvSpPr/>
+          <p:nvPr/>
+        </p:nvSpPr>
+        <p:spPr>
+          <a:xfrm>
+            <a:off x="7662672" y="7104888"/>
             <a:ext cx="1207008" cy="347472"/>
           </a:xfrm>
           <a:prstGeom prst="rect">
@@ -6014,13 +6185,13 @@
       </p:sp>
       <p:sp>
         <p:nvSpPr>
-          <p:cNvPr id="144" name="Shape 142"/>
-          <p:cNvSpPr/>
-          <p:nvPr/>
-        </p:nvSpPr>
-        <p:spPr>
-          <a:xfrm>
-            <a:off x="8869680" y="6510528"/>
+          <p:cNvPr id="145" name="Shape 143"/>
+          <p:cNvSpPr/>
+          <p:nvPr/>
+        </p:nvSpPr>
+        <p:spPr>
+          <a:xfrm>
+            <a:off x="8869680" y="7104888"/>
             <a:ext cx="1207008" cy="347472"/>
           </a:xfrm>
           <a:prstGeom prst="rect">
@@ -6039,13 +6210,13 @@
       </p:sp>
       <p:sp>
         <p:nvSpPr>
-          <p:cNvPr id="145" name="Text 143"/>
-          <p:cNvSpPr/>
-          <p:nvPr/>
-        </p:nvSpPr>
-        <p:spPr>
-          <a:xfrm>
-            <a:off x="8869680" y="6510528"/>
+          <p:cNvPr id="146" name="Text 144"/>
+          <p:cNvSpPr/>
+          <p:nvPr/>
+        </p:nvSpPr>
+        <p:spPr>
+          <a:xfrm>
+            <a:off x="8869680" y="7104888"/>
             <a:ext cx="1207008" cy="347472"/>
           </a:xfrm>
           <a:prstGeom prst="rect">
@@ -6078,13 +6249,13 @@
       </p:sp>
       <p:sp>
         <p:nvSpPr>
-          <p:cNvPr id="146" name="Shape 144"/>
-          <p:cNvSpPr/>
-          <p:nvPr/>
-        </p:nvSpPr>
-        <p:spPr>
-          <a:xfrm>
-            <a:off x="10076688" y="6510528"/>
+          <p:cNvPr id="147" name="Shape 145"/>
+          <p:cNvSpPr/>
+          <p:nvPr/>
+        </p:nvSpPr>
+        <p:spPr>
+          <a:xfrm>
+            <a:off x="10076688" y="7104888"/>
             <a:ext cx="1207008" cy="347472"/>
           </a:xfrm>
           <a:prstGeom prst="rect">
@@ -6103,13 +6274,13 @@
       </p:sp>
       <p:sp>
         <p:nvSpPr>
-          <p:cNvPr id="147" name="Text 145"/>
-          <p:cNvSpPr/>
-          <p:nvPr/>
-        </p:nvSpPr>
-        <p:spPr>
-          <a:xfrm>
-            <a:off x="10076688" y="6510528"/>
+          <p:cNvPr id="148" name="Text 146"/>
+          <p:cNvSpPr/>
+          <p:nvPr/>
+        </p:nvSpPr>
+        <p:spPr>
+          <a:xfrm>
+            <a:off x="10076688" y="7104888"/>
             <a:ext cx="1207008" cy="347472"/>
           </a:xfrm>
           <a:prstGeom prst="rect">
@@ -6142,13 +6313,13 @@
       </p:sp>
       <p:sp>
         <p:nvSpPr>
-          <p:cNvPr id="148" name="Shape 146"/>
-          <p:cNvSpPr/>
-          <p:nvPr/>
-        </p:nvSpPr>
-        <p:spPr>
-          <a:xfrm>
-            <a:off x="11283696" y="6510528"/>
+          <p:cNvPr id="149" name="Shape 147"/>
+          <p:cNvSpPr/>
+          <p:nvPr/>
+        </p:nvSpPr>
+        <p:spPr>
+          <a:xfrm>
+            <a:off x="11283696" y="7104888"/>
             <a:ext cx="1207008" cy="347472"/>
           </a:xfrm>
           <a:prstGeom prst="rect">
@@ -6167,13 +6338,13 @@
       </p:sp>
       <p:sp>
         <p:nvSpPr>
-          <p:cNvPr id="149" name="Text 147"/>
-          <p:cNvSpPr/>
-          <p:nvPr/>
-        </p:nvSpPr>
-        <p:spPr>
-          <a:xfrm>
-            <a:off x="11283696" y="6510528"/>
+          <p:cNvPr id="150" name="Text 148"/>
+          <p:cNvSpPr/>
+          <p:nvPr/>
+        </p:nvSpPr>
+        <p:spPr>
+          <a:xfrm>
+            <a:off x="11283696" y="7104888"/>
             <a:ext cx="1207008" cy="347472"/>
           </a:xfrm>
           <a:prstGeom prst="rect">
@@ -6206,13 +6377,13 @@
       </p:sp>
       <p:sp>
         <p:nvSpPr>
-          <p:cNvPr id="150" name="Shape 148"/>
-          <p:cNvSpPr/>
-          <p:nvPr/>
-        </p:nvSpPr>
-        <p:spPr>
-          <a:xfrm>
-            <a:off x="274320" y="6858000"/>
+          <p:cNvPr id="151" name="Shape 149"/>
+          <p:cNvSpPr/>
+          <p:nvPr/>
+        </p:nvSpPr>
+        <p:spPr>
+          <a:xfrm>
+            <a:off x="274320" y="7452360"/>
             <a:ext cx="2560320" cy="347472"/>
           </a:xfrm>
           <a:prstGeom prst="rect">
@@ -6231,13 +6402,13 @@
       </p:sp>
       <p:sp>
         <p:nvSpPr>
-          <p:cNvPr id="151" name="Text 149"/>
-          <p:cNvSpPr/>
-          <p:nvPr/>
-        </p:nvSpPr>
-        <p:spPr>
-          <a:xfrm>
-            <a:off x="365760" y="6858000"/>
+          <p:cNvPr id="152" name="Text 150"/>
+          <p:cNvSpPr/>
+          <p:nvPr/>
+        </p:nvSpPr>
+        <p:spPr>
+          <a:xfrm>
+            <a:off x="365760" y="7452360"/>
             <a:ext cx="2377440" cy="347472"/>
           </a:xfrm>
           <a:prstGeom prst="rect">
@@ -6270,13 +6441,13 @@
       </p:sp>
       <p:sp>
         <p:nvSpPr>
-          <p:cNvPr id="152" name="Shape 150"/>
-          <p:cNvSpPr/>
-          <p:nvPr/>
-        </p:nvSpPr>
-        <p:spPr>
-          <a:xfrm>
-            <a:off x="2834640" y="6858000"/>
+          <p:cNvPr id="153" name="Shape 151"/>
+          <p:cNvSpPr/>
+          <p:nvPr/>
+        </p:nvSpPr>
+        <p:spPr>
+          <a:xfrm>
+            <a:off x="2834640" y="7452360"/>
             <a:ext cx="1207008" cy="347472"/>
           </a:xfrm>
           <a:prstGeom prst="rect">
@@ -6295,13 +6466,13 @@
       </p:sp>
       <p:sp>
         <p:nvSpPr>
-          <p:cNvPr id="153" name="Text 151"/>
-          <p:cNvSpPr/>
-          <p:nvPr/>
-        </p:nvSpPr>
-        <p:spPr>
-          <a:xfrm>
-            <a:off x="2834640" y="6858000"/>
+          <p:cNvPr id="154" name="Text 152"/>
+          <p:cNvSpPr/>
+          <p:nvPr/>
+        </p:nvSpPr>
+        <p:spPr>
+          <a:xfrm>
+            <a:off x="2834640" y="7452360"/>
             <a:ext cx="1207008" cy="347472"/>
           </a:xfrm>
           <a:prstGeom prst="rect">
@@ -6334,13 +6505,13 @@
       </p:sp>
       <p:sp>
         <p:nvSpPr>
-          <p:cNvPr id="154" name="Shape 152"/>
-          <p:cNvSpPr/>
-          <p:nvPr/>
-        </p:nvSpPr>
-        <p:spPr>
-          <a:xfrm>
-            <a:off x="4041648" y="6858000"/>
+          <p:cNvPr id="155" name="Shape 153"/>
+          <p:cNvSpPr/>
+          <p:nvPr/>
+        </p:nvSpPr>
+        <p:spPr>
+          <a:xfrm>
+            <a:off x="4041648" y="7452360"/>
             <a:ext cx="1207008" cy="347472"/>
           </a:xfrm>
           <a:prstGeom prst="rect">
@@ -6359,13 +6530,13 @@
       </p:sp>
       <p:sp>
         <p:nvSpPr>
-          <p:cNvPr id="155" name="Text 153"/>
-          <p:cNvSpPr/>
-          <p:nvPr/>
-        </p:nvSpPr>
-        <p:spPr>
-          <a:xfrm>
-            <a:off x="4041648" y="6858000"/>
+          <p:cNvPr id="156" name="Text 154"/>
+          <p:cNvSpPr/>
+          <p:nvPr/>
+        </p:nvSpPr>
+        <p:spPr>
+          <a:xfrm>
+            <a:off x="4041648" y="7452360"/>
             <a:ext cx="1207008" cy="347472"/>
           </a:xfrm>
           <a:prstGeom prst="rect">
@@ -6398,13 +6569,13 @@
       </p:sp>
       <p:sp>
         <p:nvSpPr>
-          <p:cNvPr id="156" name="Shape 154"/>
-          <p:cNvSpPr/>
-          <p:nvPr/>
-        </p:nvSpPr>
-        <p:spPr>
-          <a:xfrm>
-            <a:off x="5248656" y="6858000"/>
+          <p:cNvPr id="157" name="Shape 155"/>
+          <p:cNvSpPr/>
+          <p:nvPr/>
+        </p:nvSpPr>
+        <p:spPr>
+          <a:xfrm>
+            <a:off x="5248656" y="7452360"/>
             <a:ext cx="1207008" cy="347472"/>
           </a:xfrm>
           <a:prstGeom prst="rect">
@@ -6423,13 +6594,13 @@
       </p:sp>
       <p:sp>
         <p:nvSpPr>
-          <p:cNvPr id="157" name="Text 155"/>
-          <p:cNvSpPr/>
-          <p:nvPr/>
-        </p:nvSpPr>
-        <p:spPr>
-          <a:xfrm>
-            <a:off x="5248656" y="6858000"/>
+          <p:cNvPr id="158" name="Text 156"/>
+          <p:cNvSpPr/>
+          <p:nvPr/>
+        </p:nvSpPr>
+        <p:spPr>
+          <a:xfrm>
+            <a:off x="5248656" y="7452360"/>
             <a:ext cx="1207008" cy="347472"/>
           </a:xfrm>
           <a:prstGeom prst="rect">
@@ -6462,13 +6633,13 @@
       </p:sp>
       <p:sp>
         <p:nvSpPr>
-          <p:cNvPr id="158" name="Shape 156"/>
-          <p:cNvSpPr/>
-          <p:nvPr/>
-        </p:nvSpPr>
-        <p:spPr>
-          <a:xfrm>
-            <a:off x="6455664" y="6858000"/>
+          <p:cNvPr id="159" name="Shape 157"/>
+          <p:cNvSpPr/>
+          <p:nvPr/>
+        </p:nvSpPr>
+        <p:spPr>
+          <a:xfrm>
+            <a:off x="6455664" y="7452360"/>
             <a:ext cx="1207008" cy="347472"/>
           </a:xfrm>
           <a:prstGeom prst="rect">
@@ -6487,13 +6658,13 @@
       </p:sp>
       <p:sp>
         <p:nvSpPr>
-          <p:cNvPr id="159" name="Text 157"/>
-          <p:cNvSpPr/>
-          <p:nvPr/>
-        </p:nvSpPr>
-        <p:spPr>
-          <a:xfrm>
-            <a:off x="6455664" y="6858000"/>
+          <p:cNvPr id="160" name="Text 158"/>
+          <p:cNvSpPr/>
+          <p:nvPr/>
+        </p:nvSpPr>
+        <p:spPr>
+          <a:xfrm>
+            <a:off x="6455664" y="7452360"/>
             <a:ext cx="1207008" cy="347472"/>
           </a:xfrm>
           <a:prstGeom prst="rect">
@@ -6526,13 +6697,13 @@
       </p:sp>
       <p:sp>
         <p:nvSpPr>
-          <p:cNvPr id="160" name="Shape 158"/>
-          <p:cNvSpPr/>
-          <p:nvPr/>
-        </p:nvSpPr>
-        <p:spPr>
-          <a:xfrm>
-            <a:off x="7662672" y="6858000"/>
+          <p:cNvPr id="161" name="Shape 159"/>
+          <p:cNvSpPr/>
+          <p:nvPr/>
+        </p:nvSpPr>
+        <p:spPr>
+          <a:xfrm>
+            <a:off x="7662672" y="7452360"/>
             <a:ext cx="1207008" cy="347472"/>
           </a:xfrm>
           <a:prstGeom prst="rect">
@@ -6551,13 +6722,13 @@
       </p:sp>
       <p:sp>
         <p:nvSpPr>
-          <p:cNvPr id="161" name="Text 159"/>
-          <p:cNvSpPr/>
-          <p:nvPr/>
-        </p:nvSpPr>
-        <p:spPr>
-          <a:xfrm>
-            <a:off x="7662672" y="6858000"/>
+          <p:cNvPr id="162" name="Text 160"/>
+          <p:cNvSpPr/>
+          <p:nvPr/>
+        </p:nvSpPr>
+        <p:spPr>
+          <a:xfrm>
+            <a:off x="7662672" y="7452360"/>
             <a:ext cx="1207008" cy="347472"/>
           </a:xfrm>
           <a:prstGeom prst="rect">
@@ -6590,13 +6761,13 @@
       </p:sp>
       <p:sp>
         <p:nvSpPr>
-          <p:cNvPr id="162" name="Shape 160"/>
-          <p:cNvSpPr/>
-          <p:nvPr/>
-        </p:nvSpPr>
-        <p:spPr>
-          <a:xfrm>
-            <a:off x="8869680" y="6858000"/>
+          <p:cNvPr id="163" name="Shape 161"/>
+          <p:cNvSpPr/>
+          <p:nvPr/>
+        </p:nvSpPr>
+        <p:spPr>
+          <a:xfrm>
+            <a:off x="8869680" y="7452360"/>
             <a:ext cx="1207008" cy="347472"/>
           </a:xfrm>
           <a:prstGeom prst="rect">
@@ -6615,13 +6786,13 @@
       </p:sp>
       <p:sp>
         <p:nvSpPr>
-          <p:cNvPr id="163" name="Text 161"/>
-          <p:cNvSpPr/>
-          <p:nvPr/>
-        </p:nvSpPr>
-        <p:spPr>
-          <a:xfrm>
-            <a:off x="8869680" y="6858000"/>
+          <p:cNvPr id="164" name="Text 162"/>
+          <p:cNvSpPr/>
+          <p:nvPr/>
+        </p:nvSpPr>
+        <p:spPr>
+          <a:xfrm>
+            <a:off x="8869680" y="7452360"/>
             <a:ext cx="1207008" cy="347472"/>
           </a:xfrm>
           <a:prstGeom prst="rect">
@@ -6654,13 +6825,13 @@
       </p:sp>
       <p:sp>
         <p:nvSpPr>
-          <p:cNvPr id="164" name="Shape 162"/>
-          <p:cNvSpPr/>
-          <p:nvPr/>
-        </p:nvSpPr>
-        <p:spPr>
-          <a:xfrm>
-            <a:off x="10076688" y="6858000"/>
+          <p:cNvPr id="165" name="Shape 163"/>
+          <p:cNvSpPr/>
+          <p:nvPr/>
+        </p:nvSpPr>
+        <p:spPr>
+          <a:xfrm>
+            <a:off x="10076688" y="7452360"/>
             <a:ext cx="1207008" cy="347472"/>
           </a:xfrm>
           <a:prstGeom prst="rect">
@@ -6679,13 +6850,13 @@
       </p:sp>
       <p:sp>
         <p:nvSpPr>
-          <p:cNvPr id="165" name="Text 163"/>
-          <p:cNvSpPr/>
-          <p:nvPr/>
-        </p:nvSpPr>
-        <p:spPr>
-          <a:xfrm>
-            <a:off x="10076688" y="6858000"/>
+          <p:cNvPr id="166" name="Text 164"/>
+          <p:cNvSpPr/>
+          <p:nvPr/>
+        </p:nvSpPr>
+        <p:spPr>
+          <a:xfrm>
+            <a:off x="10076688" y="7452360"/>
             <a:ext cx="1207008" cy="347472"/>
           </a:xfrm>
           <a:prstGeom prst="rect">
@@ -6718,13 +6889,13 @@
       </p:sp>
       <p:sp>
         <p:nvSpPr>
-          <p:cNvPr id="166" name="Shape 164"/>
-          <p:cNvSpPr/>
-          <p:nvPr/>
-        </p:nvSpPr>
-        <p:spPr>
-          <a:xfrm>
-            <a:off x="11283696" y="6858000"/>
+          <p:cNvPr id="167" name="Shape 165"/>
+          <p:cNvSpPr/>
+          <p:nvPr/>
+        </p:nvSpPr>
+        <p:spPr>
+          <a:xfrm>
+            <a:off x="11283696" y="7452360"/>
             <a:ext cx="1207008" cy="347472"/>
           </a:xfrm>
           <a:prstGeom prst="rect">
@@ -6743,13 +6914,13 @@
       </p:sp>
       <p:sp>
         <p:nvSpPr>
-          <p:cNvPr id="167" name="Text 165"/>
-          <p:cNvSpPr/>
-          <p:nvPr/>
-        </p:nvSpPr>
-        <p:spPr>
-          <a:xfrm>
-            <a:off x="11283696" y="6858000"/>
+          <p:cNvPr id="168" name="Text 166"/>
+          <p:cNvSpPr/>
+          <p:nvPr/>
+        </p:nvSpPr>
+        <p:spPr>
+          <a:xfrm>
+            <a:off x="11283696" y="7452360"/>
             <a:ext cx="1207008" cy="347472"/>
           </a:xfrm>
           <a:prstGeom prst="rect">
@@ -6782,13 +6953,13 @@
       </p:sp>
       <p:sp>
         <p:nvSpPr>
-          <p:cNvPr id="168" name="Shape 166"/>
-          <p:cNvSpPr/>
-          <p:nvPr/>
-        </p:nvSpPr>
-        <p:spPr>
-          <a:xfrm>
-            <a:off x="274320" y="7205472"/>
+          <p:cNvPr id="169" name="Shape 167"/>
+          <p:cNvSpPr/>
+          <p:nvPr/>
+        </p:nvSpPr>
+        <p:spPr>
+          <a:xfrm>
+            <a:off x="274320" y="7799832"/>
             <a:ext cx="2560320" cy="347472"/>
           </a:xfrm>
           <a:prstGeom prst="rect">
@@ -6807,13 +6978,13 @@
       </p:sp>
       <p:sp>
         <p:nvSpPr>
-          <p:cNvPr id="169" name="Text 167"/>
-          <p:cNvSpPr/>
-          <p:nvPr/>
-        </p:nvSpPr>
-        <p:spPr>
-          <a:xfrm>
-            <a:off x="365760" y="7205472"/>
+          <p:cNvPr id="170" name="Text 168"/>
+          <p:cNvSpPr/>
+          <p:nvPr/>
+        </p:nvSpPr>
+        <p:spPr>
+          <a:xfrm>
+            <a:off x="365760" y="7799832"/>
             <a:ext cx="2377440" cy="347472"/>
           </a:xfrm>
           <a:prstGeom prst="rect">
@@ -6846,13 +7017,13 @@
       </p:sp>
       <p:sp>
         <p:nvSpPr>
-          <p:cNvPr id="170" name="Shape 168"/>
-          <p:cNvSpPr/>
-          <p:nvPr/>
-        </p:nvSpPr>
-        <p:spPr>
-          <a:xfrm>
-            <a:off x="2834640" y="7205472"/>
+          <p:cNvPr id="171" name="Shape 169"/>
+          <p:cNvSpPr/>
+          <p:nvPr/>
+        </p:nvSpPr>
+        <p:spPr>
+          <a:xfrm>
+            <a:off x="2834640" y="7799832"/>
             <a:ext cx="1207008" cy="347472"/>
           </a:xfrm>
           <a:prstGeom prst="rect">
@@ -6871,13 +7042,13 @@
       </p:sp>
       <p:sp>
         <p:nvSpPr>
-          <p:cNvPr id="171" name="Text 169"/>
-          <p:cNvSpPr/>
-          <p:nvPr/>
-        </p:nvSpPr>
-        <p:spPr>
-          <a:xfrm>
-            <a:off x="2834640" y="7205472"/>
+          <p:cNvPr id="172" name="Text 170"/>
+          <p:cNvSpPr/>
+          <p:nvPr/>
+        </p:nvSpPr>
+        <p:spPr>
+          <a:xfrm>
+            <a:off x="2834640" y="7799832"/>
             <a:ext cx="1207008" cy="347472"/>
           </a:xfrm>
           <a:prstGeom prst="rect">
@@ -6910,13 +7081,13 @@
       </p:sp>
       <p:sp>
         <p:nvSpPr>
-          <p:cNvPr id="172" name="Shape 170"/>
-          <p:cNvSpPr/>
-          <p:nvPr/>
-        </p:nvSpPr>
-        <p:spPr>
-          <a:xfrm>
-            <a:off x="4041648" y="7205472"/>
+          <p:cNvPr id="173" name="Shape 171"/>
+          <p:cNvSpPr/>
+          <p:nvPr/>
+        </p:nvSpPr>
+        <p:spPr>
+          <a:xfrm>
+            <a:off x="4041648" y="7799832"/>
             <a:ext cx="1207008" cy="347472"/>
           </a:xfrm>
           <a:prstGeom prst="rect">
@@ -6935,13 +7106,13 @@
       </p:sp>
       <p:sp>
         <p:nvSpPr>
-          <p:cNvPr id="173" name="Text 171"/>
-          <p:cNvSpPr/>
-          <p:nvPr/>
-        </p:nvSpPr>
-        <p:spPr>
-          <a:xfrm>
-            <a:off x="4041648" y="7205472"/>
+          <p:cNvPr id="174" name="Text 172"/>
+          <p:cNvSpPr/>
+          <p:nvPr/>
+        </p:nvSpPr>
+        <p:spPr>
+          <a:xfrm>
+            <a:off x="4041648" y="7799832"/>
             <a:ext cx="1207008" cy="347472"/>
           </a:xfrm>
           <a:prstGeom prst="rect">
@@ -6974,13 +7145,13 @@
       </p:sp>
       <p:sp>
         <p:nvSpPr>
-          <p:cNvPr id="174" name="Shape 172"/>
-          <p:cNvSpPr/>
-          <p:nvPr/>
-        </p:nvSpPr>
-        <p:spPr>
-          <a:xfrm>
-            <a:off x="5248656" y="7205472"/>
+          <p:cNvPr id="175" name="Shape 173"/>
+          <p:cNvSpPr/>
+          <p:nvPr/>
+        </p:nvSpPr>
+        <p:spPr>
+          <a:xfrm>
+            <a:off x="5248656" y="7799832"/>
             <a:ext cx="1207008" cy="347472"/>
           </a:xfrm>
           <a:prstGeom prst="rect">
@@ -6999,13 +7170,13 @@
       </p:sp>
       <p:sp>
         <p:nvSpPr>
-          <p:cNvPr id="175" name="Text 173"/>
-          <p:cNvSpPr/>
-          <p:nvPr/>
-        </p:nvSpPr>
-        <p:spPr>
-          <a:xfrm>
-            <a:off x="5248656" y="7205472"/>
+          <p:cNvPr id="176" name="Text 174"/>
+          <p:cNvSpPr/>
+          <p:nvPr/>
+        </p:nvSpPr>
+        <p:spPr>
+          <a:xfrm>
+            <a:off x="5248656" y="7799832"/>
             <a:ext cx="1207008" cy="347472"/>
           </a:xfrm>
           <a:prstGeom prst="rect">
@@ -7038,13 +7209,13 @@
       </p:sp>
       <p:sp>
         <p:nvSpPr>
-          <p:cNvPr id="176" name="Shape 174"/>
-          <p:cNvSpPr/>
-          <p:nvPr/>
-        </p:nvSpPr>
-        <p:spPr>
-          <a:xfrm>
-            <a:off x="6455664" y="7205472"/>
+          <p:cNvPr id="177" name="Shape 175"/>
+          <p:cNvSpPr/>
+          <p:nvPr/>
+        </p:nvSpPr>
+        <p:spPr>
+          <a:xfrm>
+            <a:off x="6455664" y="7799832"/>
             <a:ext cx="1207008" cy="347472"/>
           </a:xfrm>
           <a:prstGeom prst="rect">
@@ -7063,13 +7234,13 @@
       </p:sp>
       <p:sp>
         <p:nvSpPr>
-          <p:cNvPr id="177" name="Text 175"/>
-          <p:cNvSpPr/>
-          <p:nvPr/>
-        </p:nvSpPr>
-        <p:spPr>
-          <a:xfrm>
-            <a:off x="6455664" y="7205472"/>
+          <p:cNvPr id="178" name="Text 176"/>
+          <p:cNvSpPr/>
+          <p:nvPr/>
+        </p:nvSpPr>
+        <p:spPr>
+          <a:xfrm>
+            <a:off x="6455664" y="7799832"/>
             <a:ext cx="1207008" cy="347472"/>
           </a:xfrm>
           <a:prstGeom prst="rect">
@@ -7102,13 +7273,13 @@
       </p:sp>
       <p:sp>
         <p:nvSpPr>
-          <p:cNvPr id="178" name="Shape 176"/>
-          <p:cNvSpPr/>
-          <p:nvPr/>
-        </p:nvSpPr>
-        <p:spPr>
-          <a:xfrm>
-            <a:off x="7662672" y="7205472"/>
+          <p:cNvPr id="179" name="Shape 177"/>
+          <p:cNvSpPr/>
+          <p:nvPr/>
+        </p:nvSpPr>
+        <p:spPr>
+          <a:xfrm>
+            <a:off x="7662672" y="7799832"/>
             <a:ext cx="1207008" cy="347472"/>
           </a:xfrm>
           <a:prstGeom prst="rect">
@@ -7127,13 +7298,13 @@
       </p:sp>
       <p:sp>
         <p:nvSpPr>
-          <p:cNvPr id="179" name="Text 177"/>
-          <p:cNvSpPr/>
-          <p:nvPr/>
-        </p:nvSpPr>
-        <p:spPr>
-          <a:xfrm>
-            <a:off x="7662672" y="7205472"/>
+          <p:cNvPr id="180" name="Text 178"/>
+          <p:cNvSpPr/>
+          <p:nvPr/>
+        </p:nvSpPr>
+        <p:spPr>
+          <a:xfrm>
+            <a:off x="7662672" y="7799832"/>
             <a:ext cx="1207008" cy="347472"/>
           </a:xfrm>
           <a:prstGeom prst="rect">
@@ -7166,13 +7337,13 @@
       </p:sp>
       <p:sp>
         <p:nvSpPr>
-          <p:cNvPr id="180" name="Shape 178"/>
-          <p:cNvSpPr/>
-          <p:nvPr/>
-        </p:nvSpPr>
-        <p:spPr>
-          <a:xfrm>
-            <a:off x="8869680" y="7205472"/>
+          <p:cNvPr id="181" name="Shape 179"/>
+          <p:cNvSpPr/>
+          <p:nvPr/>
+        </p:nvSpPr>
+        <p:spPr>
+          <a:xfrm>
+            <a:off x="8869680" y="7799832"/>
             <a:ext cx="1207008" cy="347472"/>
           </a:xfrm>
           <a:prstGeom prst="rect">
@@ -7191,13 +7362,13 @@
       </p:sp>
       <p:sp>
         <p:nvSpPr>
-          <p:cNvPr id="181" name="Text 179"/>
-          <p:cNvSpPr/>
-          <p:nvPr/>
-        </p:nvSpPr>
-        <p:spPr>
-          <a:xfrm>
-            <a:off x="8869680" y="7205472"/>
+          <p:cNvPr id="182" name="Text 180"/>
+          <p:cNvSpPr/>
+          <p:nvPr/>
+        </p:nvSpPr>
+        <p:spPr>
+          <a:xfrm>
+            <a:off x="8869680" y="7799832"/>
             <a:ext cx="1207008" cy="347472"/>
           </a:xfrm>
           <a:prstGeom prst="rect">
@@ -7230,13 +7401,13 @@
       </p:sp>
       <p:sp>
         <p:nvSpPr>
-          <p:cNvPr id="182" name="Shape 180"/>
-          <p:cNvSpPr/>
-          <p:nvPr/>
-        </p:nvSpPr>
-        <p:spPr>
-          <a:xfrm>
-            <a:off x="10076688" y="7205472"/>
+          <p:cNvPr id="183" name="Shape 181"/>
+          <p:cNvSpPr/>
+          <p:nvPr/>
+        </p:nvSpPr>
+        <p:spPr>
+          <a:xfrm>
+            <a:off x="10076688" y="7799832"/>
             <a:ext cx="1207008" cy="347472"/>
           </a:xfrm>
           <a:prstGeom prst="rect">
@@ -7255,13 +7426,13 @@
       </p:sp>
       <p:sp>
         <p:nvSpPr>
-          <p:cNvPr id="183" name="Text 181"/>
-          <p:cNvSpPr/>
-          <p:nvPr/>
-        </p:nvSpPr>
-        <p:spPr>
-          <a:xfrm>
-            <a:off x="10076688" y="7205472"/>
+          <p:cNvPr id="184" name="Text 182"/>
+          <p:cNvSpPr/>
+          <p:nvPr/>
+        </p:nvSpPr>
+        <p:spPr>
+          <a:xfrm>
+            <a:off x="10076688" y="7799832"/>
             <a:ext cx="1207008" cy="347472"/>
           </a:xfrm>
           <a:prstGeom prst="rect">
@@ -7294,13 +7465,13 @@
       </p:sp>
       <p:sp>
         <p:nvSpPr>
-          <p:cNvPr id="184" name="Shape 182"/>
-          <p:cNvSpPr/>
-          <p:nvPr/>
-        </p:nvSpPr>
-        <p:spPr>
-          <a:xfrm>
-            <a:off x="11283696" y="7205472"/>
+          <p:cNvPr id="185" name="Shape 183"/>
+          <p:cNvSpPr/>
+          <p:nvPr/>
+        </p:nvSpPr>
+        <p:spPr>
+          <a:xfrm>
+            <a:off x="11283696" y="7799832"/>
             <a:ext cx="1207008" cy="347472"/>
           </a:xfrm>
           <a:prstGeom prst="rect">
@@ -7319,13 +7490,13 @@
       </p:sp>
       <p:sp>
         <p:nvSpPr>
-          <p:cNvPr id="185" name="Text 183"/>
-          <p:cNvSpPr/>
-          <p:nvPr/>
-        </p:nvSpPr>
-        <p:spPr>
-          <a:xfrm>
-            <a:off x="11283696" y="7205472"/>
+          <p:cNvPr id="186" name="Text 184"/>
+          <p:cNvSpPr/>
+          <p:nvPr/>
+        </p:nvSpPr>
+        <p:spPr>
+          <a:xfrm>
+            <a:off x="11283696" y="7799832"/>
             <a:ext cx="1207008" cy="347472"/>
           </a:xfrm>
           <a:prstGeom prst="rect">
@@ -7358,13 +7529,13 @@
       </p:sp>
       <p:sp>
         <p:nvSpPr>
-          <p:cNvPr id="186" name="Shape 184"/>
-          <p:cNvSpPr/>
-          <p:nvPr/>
-        </p:nvSpPr>
-        <p:spPr>
-          <a:xfrm>
-            <a:off x="274320" y="7552944"/>
+          <p:cNvPr id="187" name="Shape 185"/>
+          <p:cNvSpPr/>
+          <p:nvPr/>
+        </p:nvSpPr>
+        <p:spPr>
+          <a:xfrm>
+            <a:off x="274320" y="8147304"/>
             <a:ext cx="2560320" cy="347472"/>
           </a:xfrm>
           <a:prstGeom prst="rect">
@@ -7383,13 +7554,13 @@
       </p:sp>
       <p:sp>
         <p:nvSpPr>
-          <p:cNvPr id="187" name="Text 185"/>
-          <p:cNvSpPr/>
-          <p:nvPr/>
-        </p:nvSpPr>
-        <p:spPr>
-          <a:xfrm>
-            <a:off x="365760" y="7552944"/>
+          <p:cNvPr id="188" name="Text 186"/>
+          <p:cNvSpPr/>
+          <p:nvPr/>
+        </p:nvSpPr>
+        <p:spPr>
+          <a:xfrm>
+            <a:off x="365760" y="8147304"/>
             <a:ext cx="2377440" cy="347472"/>
           </a:xfrm>
           <a:prstGeom prst="rect">
@@ -7422,13 +7593,13 @@
       </p:sp>
       <p:sp>
         <p:nvSpPr>
-          <p:cNvPr id="188" name="Shape 186"/>
-          <p:cNvSpPr/>
-          <p:nvPr/>
-        </p:nvSpPr>
-        <p:spPr>
-          <a:xfrm>
-            <a:off x="2834640" y="7552944"/>
+          <p:cNvPr id="189" name="Shape 187"/>
+          <p:cNvSpPr/>
+          <p:nvPr/>
+        </p:nvSpPr>
+        <p:spPr>
+          <a:xfrm>
+            <a:off x="2834640" y="8147304"/>
             <a:ext cx="1207008" cy="347472"/>
           </a:xfrm>
           <a:prstGeom prst="rect">
@@ -7447,13 +7618,13 @@
       </p:sp>
       <p:sp>
         <p:nvSpPr>
-          <p:cNvPr id="189" name="Text 187"/>
-          <p:cNvSpPr/>
-          <p:nvPr/>
-        </p:nvSpPr>
-        <p:spPr>
-          <a:xfrm>
-            <a:off x="2834640" y="7552944"/>
+          <p:cNvPr id="190" name="Text 188"/>
+          <p:cNvSpPr/>
+          <p:nvPr/>
+        </p:nvSpPr>
+        <p:spPr>
+          <a:xfrm>
+            <a:off x="2834640" y="8147304"/>
             <a:ext cx="1207008" cy="347472"/>
           </a:xfrm>
           <a:prstGeom prst="rect">
@@ -7486,13 +7657,13 @@
       </p:sp>
       <p:sp>
         <p:nvSpPr>
-          <p:cNvPr id="190" name="Shape 188"/>
-          <p:cNvSpPr/>
-          <p:nvPr/>
-        </p:nvSpPr>
-        <p:spPr>
-          <a:xfrm>
-            <a:off x="4041648" y="7552944"/>
+          <p:cNvPr id="191" name="Shape 189"/>
+          <p:cNvSpPr/>
+          <p:nvPr/>
+        </p:nvSpPr>
+        <p:spPr>
+          <a:xfrm>
+            <a:off x="4041648" y="8147304"/>
             <a:ext cx="1207008" cy="347472"/>
           </a:xfrm>
           <a:prstGeom prst="rect">
@@ -7511,13 +7682,13 @@
       </p:sp>
       <p:sp>
         <p:nvSpPr>
-          <p:cNvPr id="191" name="Text 189"/>
-          <p:cNvSpPr/>
-          <p:nvPr/>
-        </p:nvSpPr>
-        <p:spPr>
-          <a:xfrm>
-            <a:off x="4041648" y="7552944"/>
+          <p:cNvPr id="192" name="Text 190"/>
+          <p:cNvSpPr/>
+          <p:nvPr/>
+        </p:nvSpPr>
+        <p:spPr>
+          <a:xfrm>
+            <a:off x="4041648" y="8147304"/>
             <a:ext cx="1207008" cy="347472"/>
           </a:xfrm>
           <a:prstGeom prst="rect">
@@ -7550,13 +7721,13 @@
       </p:sp>
       <p:sp>
         <p:nvSpPr>
-          <p:cNvPr id="192" name="Shape 190"/>
-          <p:cNvSpPr/>
-          <p:nvPr/>
-        </p:nvSpPr>
-        <p:spPr>
-          <a:xfrm>
-            <a:off x="5248656" y="7552944"/>
+          <p:cNvPr id="193" name="Shape 191"/>
+          <p:cNvSpPr/>
+          <p:nvPr/>
+        </p:nvSpPr>
+        <p:spPr>
+          <a:xfrm>
+            <a:off x="5248656" y="8147304"/>
             <a:ext cx="1207008" cy="347472"/>
           </a:xfrm>
           <a:prstGeom prst="rect">
@@ -7575,13 +7746,13 @@
       </p:sp>
       <p:sp>
         <p:nvSpPr>
-          <p:cNvPr id="193" name="Text 191"/>
-          <p:cNvSpPr/>
-          <p:nvPr/>
-        </p:nvSpPr>
-        <p:spPr>
-          <a:xfrm>
-            <a:off x="5248656" y="7552944"/>
+          <p:cNvPr id="194" name="Text 192"/>
+          <p:cNvSpPr/>
+          <p:nvPr/>
+        </p:nvSpPr>
+        <p:spPr>
+          <a:xfrm>
+            <a:off x="5248656" y="8147304"/>
             <a:ext cx="1207008" cy="347472"/>
           </a:xfrm>
           <a:prstGeom prst="rect">
@@ -7614,13 +7785,13 @@
       </p:sp>
       <p:sp>
         <p:nvSpPr>
-          <p:cNvPr id="194" name="Shape 192"/>
-          <p:cNvSpPr/>
-          <p:nvPr/>
-        </p:nvSpPr>
-        <p:spPr>
-          <a:xfrm>
-            <a:off x="6455664" y="7552944"/>
+          <p:cNvPr id="195" name="Shape 193"/>
+          <p:cNvSpPr/>
+          <p:nvPr/>
+        </p:nvSpPr>
+        <p:spPr>
+          <a:xfrm>
+            <a:off x="6455664" y="8147304"/>
             <a:ext cx="1207008" cy="347472"/>
           </a:xfrm>
           <a:prstGeom prst="rect">
@@ -7639,13 +7810,13 @@
       </p:sp>
       <p:sp>
         <p:nvSpPr>
-          <p:cNvPr id="195" name="Text 193"/>
-          <p:cNvSpPr/>
-          <p:nvPr/>
-        </p:nvSpPr>
-        <p:spPr>
-          <a:xfrm>
-            <a:off x="6455664" y="7552944"/>
+          <p:cNvPr id="196" name="Text 194"/>
+          <p:cNvSpPr/>
+          <p:nvPr/>
+        </p:nvSpPr>
+        <p:spPr>
+          <a:xfrm>
+            <a:off x="6455664" y="8147304"/>
             <a:ext cx="1207008" cy="347472"/>
           </a:xfrm>
           <a:prstGeom prst="rect">
@@ -7678,13 +7849,13 @@
       </p:sp>
       <p:sp>
         <p:nvSpPr>
-          <p:cNvPr id="196" name="Shape 194"/>
-          <p:cNvSpPr/>
-          <p:nvPr/>
-        </p:nvSpPr>
-        <p:spPr>
-          <a:xfrm>
-            <a:off x="7662672" y="7552944"/>
+          <p:cNvPr id="197" name="Shape 195"/>
+          <p:cNvSpPr/>
+          <p:nvPr/>
+        </p:nvSpPr>
+        <p:spPr>
+          <a:xfrm>
+            <a:off x="7662672" y="8147304"/>
             <a:ext cx="1207008" cy="347472"/>
           </a:xfrm>
           <a:prstGeom prst="rect">
@@ -7703,13 +7874,13 @@
       </p:sp>
       <p:sp>
         <p:nvSpPr>
-          <p:cNvPr id="197" name="Text 195"/>
-          <p:cNvSpPr/>
-          <p:nvPr/>
-        </p:nvSpPr>
-        <p:spPr>
-          <a:xfrm>
-            <a:off x="7662672" y="7552944"/>
+          <p:cNvPr id="198" name="Text 196"/>
+          <p:cNvSpPr/>
+          <p:nvPr/>
+        </p:nvSpPr>
+        <p:spPr>
+          <a:xfrm>
+            <a:off x="7662672" y="8147304"/>
             <a:ext cx="1207008" cy="347472"/>
           </a:xfrm>
           <a:prstGeom prst="rect">
@@ -7742,13 +7913,13 @@
       </p:sp>
       <p:sp>
         <p:nvSpPr>
-          <p:cNvPr id="198" name="Shape 196"/>
-          <p:cNvSpPr/>
-          <p:nvPr/>
-        </p:nvSpPr>
-        <p:spPr>
-          <a:xfrm>
-            <a:off x="8869680" y="7552944"/>
+          <p:cNvPr id="199" name="Shape 197"/>
+          <p:cNvSpPr/>
+          <p:nvPr/>
+        </p:nvSpPr>
+        <p:spPr>
+          <a:xfrm>
+            <a:off x="8869680" y="8147304"/>
             <a:ext cx="1207008" cy="347472"/>
           </a:xfrm>
           <a:prstGeom prst="rect">
@@ -7767,13 +7938,13 @@
       </p:sp>
       <p:sp>
         <p:nvSpPr>
-          <p:cNvPr id="199" name="Text 197"/>
-          <p:cNvSpPr/>
-          <p:nvPr/>
-        </p:nvSpPr>
-        <p:spPr>
-          <a:xfrm>
-            <a:off x="8869680" y="7552944"/>
+          <p:cNvPr id="200" name="Text 198"/>
+          <p:cNvSpPr/>
+          <p:nvPr/>
+        </p:nvSpPr>
+        <p:spPr>
+          <a:xfrm>
+            <a:off x="8869680" y="8147304"/>
             <a:ext cx="1207008" cy="347472"/>
           </a:xfrm>
           <a:prstGeom prst="rect">
@@ -7806,13 +7977,13 @@
       </p:sp>
       <p:sp>
         <p:nvSpPr>
-          <p:cNvPr id="200" name="Shape 198"/>
-          <p:cNvSpPr/>
-          <p:nvPr/>
-        </p:nvSpPr>
-        <p:spPr>
-          <a:xfrm>
-            <a:off x="10076688" y="7552944"/>
+          <p:cNvPr id="201" name="Shape 199"/>
+          <p:cNvSpPr/>
+          <p:nvPr/>
+        </p:nvSpPr>
+        <p:spPr>
+          <a:xfrm>
+            <a:off x="10076688" y="8147304"/>
             <a:ext cx="1207008" cy="347472"/>
           </a:xfrm>
           <a:prstGeom prst="rect">
@@ -7831,13 +8002,13 @@
       </p:sp>
       <p:sp>
         <p:nvSpPr>
-          <p:cNvPr id="201" name="Text 199"/>
-          <p:cNvSpPr/>
-          <p:nvPr/>
-        </p:nvSpPr>
-        <p:spPr>
-          <a:xfrm>
-            <a:off x="10076688" y="7552944"/>
+          <p:cNvPr id="202" name="Text 200"/>
+          <p:cNvSpPr/>
+          <p:nvPr/>
+        </p:nvSpPr>
+        <p:spPr>
+          <a:xfrm>
+            <a:off x="10076688" y="8147304"/>
             <a:ext cx="1207008" cy="347472"/>
           </a:xfrm>
           <a:prstGeom prst="rect">
@@ -7870,13 +8041,13 @@
       </p:sp>
       <p:sp>
         <p:nvSpPr>
-          <p:cNvPr id="202" name="Shape 200"/>
-          <p:cNvSpPr/>
-          <p:nvPr/>
-        </p:nvSpPr>
-        <p:spPr>
-          <a:xfrm>
-            <a:off x="11283696" y="7552944"/>
+          <p:cNvPr id="203" name="Shape 201"/>
+          <p:cNvSpPr/>
+          <p:nvPr/>
+        </p:nvSpPr>
+        <p:spPr>
+          <a:xfrm>
+            <a:off x="11283696" y="8147304"/>
             <a:ext cx="1207008" cy="347472"/>
           </a:xfrm>
           <a:prstGeom prst="rect">
@@ -7895,13 +8066,13 @@
       </p:sp>
       <p:sp>
         <p:nvSpPr>
-          <p:cNvPr id="203" name="Text 201"/>
-          <p:cNvSpPr/>
-          <p:nvPr/>
-        </p:nvSpPr>
-        <p:spPr>
-          <a:xfrm>
-            <a:off x="11283696" y="7552944"/>
+          <p:cNvPr id="204" name="Text 202"/>
+          <p:cNvSpPr/>
+          <p:nvPr/>
+        </p:nvSpPr>
+        <p:spPr>
+          <a:xfrm>
+            <a:off x="11283696" y="8147304"/>
             <a:ext cx="1207008" cy="347472"/>
           </a:xfrm>
           <a:prstGeom prst="rect">
@@ -7934,13 +8105,13 @@
       </p:sp>
       <p:sp>
         <p:nvSpPr>
-          <p:cNvPr id="204" name="Shape 202"/>
-          <p:cNvSpPr/>
-          <p:nvPr/>
-        </p:nvSpPr>
-        <p:spPr>
-          <a:xfrm>
-            <a:off x="274320" y="7900416"/>
+          <p:cNvPr id="205" name="Shape 203"/>
+          <p:cNvSpPr/>
+          <p:nvPr/>
+        </p:nvSpPr>
+        <p:spPr>
+          <a:xfrm>
+            <a:off x="274320" y="8494776"/>
             <a:ext cx="2560320" cy="347472"/>
           </a:xfrm>
           <a:prstGeom prst="rect">
@@ -7959,13 +8130,13 @@
       </p:sp>
       <p:sp>
         <p:nvSpPr>
-          <p:cNvPr id="205" name="Text 203"/>
-          <p:cNvSpPr/>
-          <p:nvPr/>
-        </p:nvSpPr>
-        <p:spPr>
-          <a:xfrm>
-            <a:off x="365760" y="7900416"/>
+          <p:cNvPr id="206" name="Text 204"/>
+          <p:cNvSpPr/>
+          <p:nvPr/>
+        </p:nvSpPr>
+        <p:spPr>
+          <a:xfrm>
+            <a:off x="365760" y="8494776"/>
             <a:ext cx="2377440" cy="347472"/>
           </a:xfrm>
           <a:prstGeom prst="rect">
@@ -7998,13 +8169,13 @@
       </p:sp>
       <p:sp>
         <p:nvSpPr>
-          <p:cNvPr id="206" name="Shape 204"/>
-          <p:cNvSpPr/>
-          <p:nvPr/>
-        </p:nvSpPr>
-        <p:spPr>
-          <a:xfrm>
-            <a:off x="2834640" y="7900416"/>
+          <p:cNvPr id="207" name="Shape 205"/>
+          <p:cNvSpPr/>
+          <p:nvPr/>
+        </p:nvSpPr>
+        <p:spPr>
+          <a:xfrm>
+            <a:off x="2834640" y="8494776"/>
             <a:ext cx="1207008" cy="347472"/>
           </a:xfrm>
           <a:prstGeom prst="rect">
@@ -8023,13 +8194,13 @@
       </p:sp>
       <p:sp>
         <p:nvSpPr>
-          <p:cNvPr id="207" name="Text 205"/>
-          <p:cNvSpPr/>
-          <p:nvPr/>
-        </p:nvSpPr>
-        <p:spPr>
-          <a:xfrm>
-            <a:off x="2834640" y="7900416"/>
+          <p:cNvPr id="208" name="Text 206"/>
+          <p:cNvSpPr/>
+          <p:nvPr/>
+        </p:nvSpPr>
+        <p:spPr>
+          <a:xfrm>
+            <a:off x="2834640" y="8494776"/>
             <a:ext cx="1207008" cy="347472"/>
           </a:xfrm>
           <a:prstGeom prst="rect">
@@ -8062,13 +8233,13 @@
       </p:sp>
       <p:sp>
         <p:nvSpPr>
-          <p:cNvPr id="208" name="Shape 206"/>
-          <p:cNvSpPr/>
-          <p:nvPr/>
-        </p:nvSpPr>
-        <p:spPr>
-          <a:xfrm>
-            <a:off x="4041648" y="7900416"/>
+          <p:cNvPr id="209" name="Shape 207"/>
+          <p:cNvSpPr/>
+          <p:nvPr/>
+        </p:nvSpPr>
+        <p:spPr>
+          <a:xfrm>
+            <a:off x="4041648" y="8494776"/>
             <a:ext cx="1207008" cy="347472"/>
           </a:xfrm>
           <a:prstGeom prst="rect">
@@ -8087,13 +8258,13 @@
       </p:sp>
       <p:sp>
         <p:nvSpPr>
-          <p:cNvPr id="209" name="Text 207"/>
-          <p:cNvSpPr/>
-          <p:nvPr/>
-        </p:nvSpPr>
-        <p:spPr>
-          <a:xfrm>
-            <a:off x="4041648" y="7900416"/>
+          <p:cNvPr id="210" name="Text 208"/>
+          <p:cNvSpPr/>
+          <p:nvPr/>
+        </p:nvSpPr>
+        <p:spPr>
+          <a:xfrm>
+            <a:off x="4041648" y="8494776"/>
             <a:ext cx="1207008" cy="347472"/>
           </a:xfrm>
           <a:prstGeom prst="rect">
@@ -8126,13 +8297,13 @@
       </p:sp>
       <p:sp>
         <p:nvSpPr>
-          <p:cNvPr id="210" name="Shape 208"/>
-          <p:cNvSpPr/>
-          <p:nvPr/>
-        </p:nvSpPr>
-        <p:spPr>
-          <a:xfrm>
-            <a:off x="5248656" y="7900416"/>
+          <p:cNvPr id="211" name="Shape 209"/>
+          <p:cNvSpPr/>
+          <p:nvPr/>
+        </p:nvSpPr>
+        <p:spPr>
+          <a:xfrm>
+            <a:off x="5248656" y="8494776"/>
             <a:ext cx="1207008" cy="347472"/>
           </a:xfrm>
           <a:prstGeom prst="rect">
@@ -8151,13 +8322,13 @@
       </p:sp>
       <p:sp>
         <p:nvSpPr>
-          <p:cNvPr id="211" name="Text 209"/>
-          <p:cNvSpPr/>
-          <p:nvPr/>
-        </p:nvSpPr>
-        <p:spPr>
-          <a:xfrm>
-            <a:off x="5248656" y="7900416"/>
+          <p:cNvPr id="212" name="Text 210"/>
+          <p:cNvSpPr/>
+          <p:nvPr/>
+        </p:nvSpPr>
+        <p:spPr>
+          <a:xfrm>
+            <a:off x="5248656" y="8494776"/>
             <a:ext cx="1207008" cy="347472"/>
           </a:xfrm>
           <a:prstGeom prst="rect">
@@ -8190,13 +8361,13 @@
       </p:sp>
       <p:sp>
         <p:nvSpPr>
-          <p:cNvPr id="212" name="Shape 210"/>
-          <p:cNvSpPr/>
-          <p:nvPr/>
-        </p:nvSpPr>
-        <p:spPr>
-          <a:xfrm>
-            <a:off x="6455664" y="7900416"/>
+          <p:cNvPr id="213" name="Shape 211"/>
+          <p:cNvSpPr/>
+          <p:nvPr/>
+        </p:nvSpPr>
+        <p:spPr>
+          <a:xfrm>
+            <a:off x="6455664" y="8494776"/>
             <a:ext cx="1207008" cy="347472"/>
           </a:xfrm>
           <a:prstGeom prst="rect">
@@ -8215,13 +8386,13 @@
       </p:sp>
       <p:sp>
         <p:nvSpPr>
-          <p:cNvPr id="213" name="Text 211"/>
-          <p:cNvSpPr/>
-          <p:nvPr/>
-        </p:nvSpPr>
-        <p:spPr>
-          <a:xfrm>
-            <a:off x="6455664" y="7900416"/>
+          <p:cNvPr id="214" name="Text 212"/>
+          <p:cNvSpPr/>
+          <p:nvPr/>
+        </p:nvSpPr>
+        <p:spPr>
+          <a:xfrm>
+            <a:off x="6455664" y="8494776"/>
             <a:ext cx="1207008" cy="347472"/>
           </a:xfrm>
           <a:prstGeom prst="rect">
@@ -8254,13 +8425,13 @@
       </p:sp>
       <p:sp>
         <p:nvSpPr>
-          <p:cNvPr id="214" name="Shape 212"/>
-          <p:cNvSpPr/>
-          <p:nvPr/>
-        </p:nvSpPr>
-        <p:spPr>
-          <a:xfrm>
-            <a:off x="7662672" y="7900416"/>
+          <p:cNvPr id="215" name="Shape 213"/>
+          <p:cNvSpPr/>
+          <p:nvPr/>
+        </p:nvSpPr>
+        <p:spPr>
+          <a:xfrm>
+            <a:off x="7662672" y="8494776"/>
             <a:ext cx="1207008" cy="347472"/>
           </a:xfrm>
           <a:prstGeom prst="rect">
@@ -8279,13 +8450,13 @@
       </p:sp>
       <p:sp>
         <p:nvSpPr>
-          <p:cNvPr id="215" name="Text 213"/>
-          <p:cNvSpPr/>
-          <p:nvPr/>
-        </p:nvSpPr>
-        <p:spPr>
-          <a:xfrm>
-            <a:off x="7662672" y="7900416"/>
+          <p:cNvPr id="216" name="Text 214"/>
+          <p:cNvSpPr/>
+          <p:nvPr/>
+        </p:nvSpPr>
+        <p:spPr>
+          <a:xfrm>
+            <a:off x="7662672" y="8494776"/>
             <a:ext cx="1207008" cy="347472"/>
           </a:xfrm>
           <a:prstGeom prst="rect">
@@ -8318,13 +8489,13 @@
       </p:sp>
       <p:sp>
         <p:nvSpPr>
-          <p:cNvPr id="216" name="Shape 214"/>
-          <p:cNvSpPr/>
-          <p:nvPr/>
-        </p:nvSpPr>
-        <p:spPr>
-          <a:xfrm>
-            <a:off x="8869680" y="7900416"/>
+          <p:cNvPr id="217" name="Shape 215"/>
+          <p:cNvSpPr/>
+          <p:nvPr/>
+        </p:nvSpPr>
+        <p:spPr>
+          <a:xfrm>
+            <a:off x="8869680" y="8494776"/>
             <a:ext cx="1207008" cy="347472"/>
           </a:xfrm>
           <a:prstGeom prst="rect">
@@ -8343,13 +8514,13 @@
       </p:sp>
       <p:sp>
         <p:nvSpPr>
-          <p:cNvPr id="217" name="Text 215"/>
-          <p:cNvSpPr/>
-          <p:nvPr/>
-        </p:nvSpPr>
-        <p:spPr>
-          <a:xfrm>
-            <a:off x="8869680" y="7900416"/>
+          <p:cNvPr id="218" name="Text 216"/>
+          <p:cNvSpPr/>
+          <p:nvPr/>
+        </p:nvSpPr>
+        <p:spPr>
+          <a:xfrm>
+            <a:off x="8869680" y="8494776"/>
             <a:ext cx="1207008" cy="347472"/>
           </a:xfrm>
           <a:prstGeom prst="rect">
@@ -8382,13 +8553,13 @@
       </p:sp>
       <p:sp>
         <p:nvSpPr>
-          <p:cNvPr id="218" name="Shape 216"/>
-          <p:cNvSpPr/>
-          <p:nvPr/>
-        </p:nvSpPr>
-        <p:spPr>
-          <a:xfrm>
-            <a:off x="10076688" y="7900416"/>
+          <p:cNvPr id="219" name="Shape 217"/>
+          <p:cNvSpPr/>
+          <p:nvPr/>
+        </p:nvSpPr>
+        <p:spPr>
+          <a:xfrm>
+            <a:off x="10076688" y="8494776"/>
             <a:ext cx="1207008" cy="347472"/>
           </a:xfrm>
           <a:prstGeom prst="rect">
@@ -8407,13 +8578,13 @@
       </p:sp>
       <p:sp>
         <p:nvSpPr>
-          <p:cNvPr id="219" name="Text 217"/>
-          <p:cNvSpPr/>
-          <p:nvPr/>
-        </p:nvSpPr>
-        <p:spPr>
-          <a:xfrm>
-            <a:off x="10076688" y="7900416"/>
+          <p:cNvPr id="220" name="Text 218"/>
+          <p:cNvSpPr/>
+          <p:nvPr/>
+        </p:nvSpPr>
+        <p:spPr>
+          <a:xfrm>
+            <a:off x="10076688" y="8494776"/>
             <a:ext cx="1207008" cy="347472"/>
           </a:xfrm>
           <a:prstGeom prst="rect">
@@ -8446,13 +8617,13 @@
       </p:sp>
       <p:sp>
         <p:nvSpPr>
-          <p:cNvPr id="220" name="Shape 218"/>
-          <p:cNvSpPr/>
-          <p:nvPr/>
-        </p:nvSpPr>
-        <p:spPr>
-          <a:xfrm>
-            <a:off x="11283696" y="7900416"/>
+          <p:cNvPr id="221" name="Shape 219"/>
+          <p:cNvSpPr/>
+          <p:nvPr/>
+        </p:nvSpPr>
+        <p:spPr>
+          <a:xfrm>
+            <a:off x="11283696" y="8494776"/>
             <a:ext cx="1207008" cy="347472"/>
           </a:xfrm>
           <a:prstGeom prst="rect">
@@ -8471,13 +8642,13 @@
       </p:sp>
       <p:sp>
         <p:nvSpPr>
-          <p:cNvPr id="221" name="Text 219"/>
-          <p:cNvSpPr/>
-          <p:nvPr/>
-        </p:nvSpPr>
-        <p:spPr>
-          <a:xfrm>
-            <a:off x="11283696" y="7900416"/>
+          <p:cNvPr id="222" name="Text 220"/>
+          <p:cNvSpPr/>
+          <p:nvPr/>
+        </p:nvSpPr>
+        <p:spPr>
+          <a:xfrm>
+            <a:off x="11283696" y="8494776"/>
             <a:ext cx="1207008" cy="347472"/>
           </a:xfrm>
           <a:prstGeom prst="rect">
@@ -8510,13 +8681,13 @@
       </p:sp>
       <p:sp>
         <p:nvSpPr>
-          <p:cNvPr id="222" name="Shape 220"/>
-          <p:cNvSpPr/>
-          <p:nvPr/>
-        </p:nvSpPr>
-        <p:spPr>
-          <a:xfrm>
-            <a:off x="274320" y="8247888"/>
+          <p:cNvPr id="223" name="Shape 221"/>
+          <p:cNvSpPr/>
+          <p:nvPr/>
+        </p:nvSpPr>
+        <p:spPr>
+          <a:xfrm>
+            <a:off x="274320" y="8842248"/>
             <a:ext cx="2560320" cy="347472"/>
           </a:xfrm>
           <a:prstGeom prst="rect">
@@ -8535,13 +8706,13 @@
       </p:sp>
       <p:sp>
         <p:nvSpPr>
-          <p:cNvPr id="223" name="Text 221"/>
-          <p:cNvSpPr/>
-          <p:nvPr/>
-        </p:nvSpPr>
-        <p:spPr>
-          <a:xfrm>
-            <a:off x="365760" y="8247888"/>
+          <p:cNvPr id="224" name="Text 222"/>
+          <p:cNvSpPr/>
+          <p:nvPr/>
+        </p:nvSpPr>
+        <p:spPr>
+          <a:xfrm>
+            <a:off x="365760" y="8842248"/>
             <a:ext cx="2377440" cy="347472"/>
           </a:xfrm>
           <a:prstGeom prst="rect">
@@ -8574,13 +8745,13 @@
       </p:sp>
       <p:sp>
         <p:nvSpPr>
-          <p:cNvPr id="224" name="Shape 222"/>
-          <p:cNvSpPr/>
-          <p:nvPr/>
-        </p:nvSpPr>
-        <p:spPr>
-          <a:xfrm>
-            <a:off x="2834640" y="8247888"/>
+          <p:cNvPr id="225" name="Shape 223"/>
+          <p:cNvSpPr/>
+          <p:nvPr/>
+        </p:nvSpPr>
+        <p:spPr>
+          <a:xfrm>
+            <a:off x="2834640" y="8842248"/>
             <a:ext cx="1207008" cy="347472"/>
           </a:xfrm>
           <a:prstGeom prst="rect">
@@ -8599,13 +8770,13 @@
       </p:sp>
       <p:sp>
         <p:nvSpPr>
-          <p:cNvPr id="225" name="Text 223"/>
-          <p:cNvSpPr/>
-          <p:nvPr/>
-        </p:nvSpPr>
-        <p:spPr>
-          <a:xfrm>
-            <a:off x="2834640" y="8247888"/>
+          <p:cNvPr id="226" name="Text 224"/>
+          <p:cNvSpPr/>
+          <p:nvPr/>
+        </p:nvSpPr>
+        <p:spPr>
+          <a:xfrm>
+            <a:off x="2834640" y="8842248"/>
             <a:ext cx="1207008" cy="347472"/>
           </a:xfrm>
           <a:prstGeom prst="rect">
@@ -8638,13 +8809,13 @@
       </p:sp>
       <p:sp>
         <p:nvSpPr>
-          <p:cNvPr id="226" name="Shape 224"/>
-          <p:cNvSpPr/>
-          <p:nvPr/>
-        </p:nvSpPr>
-        <p:spPr>
-          <a:xfrm>
-            <a:off x="4041648" y="8247888"/>
+          <p:cNvPr id="227" name="Shape 225"/>
+          <p:cNvSpPr/>
+          <p:nvPr/>
+        </p:nvSpPr>
+        <p:spPr>
+          <a:xfrm>
+            <a:off x="4041648" y="8842248"/>
             <a:ext cx="1207008" cy="347472"/>
           </a:xfrm>
           <a:prstGeom prst="rect">
@@ -8663,13 +8834,13 @@
       </p:sp>
       <p:sp>
         <p:nvSpPr>
-          <p:cNvPr id="227" name="Text 225"/>
-          <p:cNvSpPr/>
-          <p:nvPr/>
-        </p:nvSpPr>
-        <p:spPr>
-          <a:xfrm>
-            <a:off x="4041648" y="8247888"/>
+          <p:cNvPr id="228" name="Text 226"/>
+          <p:cNvSpPr/>
+          <p:nvPr/>
+        </p:nvSpPr>
+        <p:spPr>
+          <a:xfrm>
+            <a:off x="4041648" y="8842248"/>
             <a:ext cx="1207008" cy="347472"/>
           </a:xfrm>
           <a:prstGeom prst="rect">
@@ -8702,13 +8873,13 @@
       </p:sp>
       <p:sp>
         <p:nvSpPr>
-          <p:cNvPr id="228" name="Shape 226"/>
-          <p:cNvSpPr/>
-          <p:nvPr/>
-        </p:nvSpPr>
-        <p:spPr>
-          <a:xfrm>
-            <a:off x="5248656" y="8247888"/>
+          <p:cNvPr id="229" name="Shape 227"/>
+          <p:cNvSpPr/>
+          <p:nvPr/>
+        </p:nvSpPr>
+        <p:spPr>
+          <a:xfrm>
+            <a:off x="5248656" y="8842248"/>
             <a:ext cx="1207008" cy="347472"/>
           </a:xfrm>
           <a:prstGeom prst="rect">
@@ -8727,13 +8898,13 @@
       </p:sp>
       <p:sp>
         <p:nvSpPr>
-          <p:cNvPr id="229" name="Text 227"/>
-          <p:cNvSpPr/>
-          <p:nvPr/>
-        </p:nvSpPr>
-        <p:spPr>
-          <a:xfrm>
-            <a:off x="5248656" y="8247888"/>
+          <p:cNvPr id="230" name="Text 228"/>
+          <p:cNvSpPr/>
+          <p:nvPr/>
+        </p:nvSpPr>
+        <p:spPr>
+          <a:xfrm>
+            <a:off x="5248656" y="8842248"/>
             <a:ext cx="1207008" cy="347472"/>
           </a:xfrm>
           <a:prstGeom prst="rect">
@@ -8766,13 +8937,13 @@
       </p:sp>
       <p:sp>
         <p:nvSpPr>
-          <p:cNvPr id="230" name="Shape 228"/>
-          <p:cNvSpPr/>
-          <p:nvPr/>
-        </p:nvSpPr>
-        <p:spPr>
-          <a:xfrm>
-            <a:off x="6455664" y="8247888"/>
+          <p:cNvPr id="231" name="Shape 229"/>
+          <p:cNvSpPr/>
+          <p:nvPr/>
+        </p:nvSpPr>
+        <p:spPr>
+          <a:xfrm>
+            <a:off x="6455664" y="8842248"/>
             <a:ext cx="1207008" cy="347472"/>
           </a:xfrm>
           <a:prstGeom prst="rect">
@@ -8791,13 +8962,13 @@
       </p:sp>
       <p:sp>
         <p:nvSpPr>
-          <p:cNvPr id="231" name="Text 229"/>
-          <p:cNvSpPr/>
-          <p:nvPr/>
-        </p:nvSpPr>
-        <p:spPr>
-          <a:xfrm>
-            <a:off x="6455664" y="8247888"/>
+          <p:cNvPr id="232" name="Text 230"/>
+          <p:cNvSpPr/>
+          <p:nvPr/>
+        </p:nvSpPr>
+        <p:spPr>
+          <a:xfrm>
+            <a:off x="6455664" y="8842248"/>
             <a:ext cx="1207008" cy="347472"/>
           </a:xfrm>
           <a:prstGeom prst="rect">
@@ -8830,13 +9001,13 @@
       </p:sp>
       <p:sp>
         <p:nvSpPr>
-          <p:cNvPr id="232" name="Shape 230"/>
-          <p:cNvSpPr/>
-          <p:nvPr/>
-        </p:nvSpPr>
-        <p:spPr>
-          <a:xfrm>
-            <a:off x="7662672" y="8247888"/>
+          <p:cNvPr id="233" name="Shape 231"/>
+          <p:cNvSpPr/>
+          <p:nvPr/>
+        </p:nvSpPr>
+        <p:spPr>
+          <a:xfrm>
+            <a:off x="7662672" y="8842248"/>
             <a:ext cx="1207008" cy="347472"/>
           </a:xfrm>
           <a:prstGeom prst="rect">
@@ -8855,13 +9026,13 @@
       </p:sp>
       <p:sp>
         <p:nvSpPr>
-          <p:cNvPr id="233" name="Text 231"/>
-          <p:cNvSpPr/>
-          <p:nvPr/>
-        </p:nvSpPr>
-        <p:spPr>
-          <a:xfrm>
-            <a:off x="7662672" y="8247888"/>
+          <p:cNvPr id="234" name="Text 232"/>
+          <p:cNvSpPr/>
+          <p:nvPr/>
+        </p:nvSpPr>
+        <p:spPr>
+          <a:xfrm>
+            <a:off x="7662672" y="8842248"/>
             <a:ext cx="1207008" cy="347472"/>
           </a:xfrm>
           <a:prstGeom prst="rect">
@@ -8894,13 +9065,13 @@
       </p:sp>
       <p:sp>
         <p:nvSpPr>
-          <p:cNvPr id="234" name="Shape 232"/>
-          <p:cNvSpPr/>
-          <p:nvPr/>
-        </p:nvSpPr>
-        <p:spPr>
-          <a:xfrm>
-            <a:off x="8869680" y="8247888"/>
+          <p:cNvPr id="235" name="Shape 233"/>
+          <p:cNvSpPr/>
+          <p:nvPr/>
+        </p:nvSpPr>
+        <p:spPr>
+          <a:xfrm>
+            <a:off x="8869680" y="8842248"/>
             <a:ext cx="1207008" cy="347472"/>
           </a:xfrm>
           <a:prstGeom prst="rect">
@@ -8919,13 +9090,13 @@
       </p:sp>
       <p:sp>
         <p:nvSpPr>
-          <p:cNvPr id="235" name="Text 233"/>
-          <p:cNvSpPr/>
-          <p:nvPr/>
-        </p:nvSpPr>
-        <p:spPr>
-          <a:xfrm>
-            <a:off x="8869680" y="8247888"/>
+          <p:cNvPr id="236" name="Text 234"/>
+          <p:cNvSpPr/>
+          <p:nvPr/>
+        </p:nvSpPr>
+        <p:spPr>
+          <a:xfrm>
+            <a:off x="8869680" y="8842248"/>
             <a:ext cx="1207008" cy="347472"/>
           </a:xfrm>
           <a:prstGeom prst="rect">
@@ -8958,13 +9129,13 @@
       </p:sp>
       <p:sp>
         <p:nvSpPr>
-          <p:cNvPr id="236" name="Shape 234"/>
-          <p:cNvSpPr/>
-          <p:nvPr/>
-        </p:nvSpPr>
-        <p:spPr>
-          <a:xfrm>
-            <a:off x="10076688" y="8247888"/>
+          <p:cNvPr id="237" name="Shape 235"/>
+          <p:cNvSpPr/>
+          <p:nvPr/>
+        </p:nvSpPr>
+        <p:spPr>
+          <a:xfrm>
+            <a:off x="10076688" y="8842248"/>
             <a:ext cx="1207008" cy="347472"/>
           </a:xfrm>
           <a:prstGeom prst="rect">
@@ -8983,13 +9154,13 @@
       </p:sp>
       <p:sp>
         <p:nvSpPr>
-          <p:cNvPr id="237" name="Text 235"/>
-          <p:cNvSpPr/>
-          <p:nvPr/>
-        </p:nvSpPr>
-        <p:spPr>
-          <a:xfrm>
-            <a:off x="10076688" y="8247888"/>
+          <p:cNvPr id="238" name="Text 236"/>
+          <p:cNvSpPr/>
+          <p:nvPr/>
+        </p:nvSpPr>
+        <p:spPr>
+          <a:xfrm>
+            <a:off x="10076688" y="8842248"/>
             <a:ext cx="1207008" cy="347472"/>
           </a:xfrm>
           <a:prstGeom prst="rect">
@@ -9022,13 +9193,13 @@
       </p:sp>
       <p:sp>
         <p:nvSpPr>
-          <p:cNvPr id="238" name="Shape 236"/>
-          <p:cNvSpPr/>
-          <p:nvPr/>
-        </p:nvSpPr>
-        <p:spPr>
-          <a:xfrm>
-            <a:off x="11283696" y="8247888"/>
+          <p:cNvPr id="239" name="Shape 237"/>
+          <p:cNvSpPr/>
+          <p:nvPr/>
+        </p:nvSpPr>
+        <p:spPr>
+          <a:xfrm>
+            <a:off x="11283696" y="8842248"/>
             <a:ext cx="1207008" cy="347472"/>
           </a:xfrm>
           <a:prstGeom prst="rect">
@@ -9047,13 +9218,13 @@
       </p:sp>
       <p:sp>
         <p:nvSpPr>
-          <p:cNvPr id="239" name="Text 237"/>
-          <p:cNvSpPr/>
-          <p:nvPr/>
-        </p:nvSpPr>
-        <p:spPr>
-          <a:xfrm>
-            <a:off x="11283696" y="8247888"/>
+          <p:cNvPr id="240" name="Text 238"/>
+          <p:cNvSpPr/>
+          <p:nvPr/>
+        </p:nvSpPr>
+        <p:spPr>
+          <a:xfrm>
+            <a:off x="11283696" y="8842248"/>
             <a:ext cx="1207008" cy="347472"/>
           </a:xfrm>
           <a:prstGeom prst="rect">
@@ -9086,13 +9257,13 @@
       </p:sp>
       <p:sp>
         <p:nvSpPr>
-          <p:cNvPr id="240" name="Text 238"/>
-          <p:cNvSpPr/>
-          <p:nvPr/>
-        </p:nvSpPr>
-        <p:spPr>
-          <a:xfrm>
-            <a:off x="274320" y="8732520"/>
+          <p:cNvPr id="241" name="Text 239"/>
+          <p:cNvSpPr/>
+          <p:nvPr/>
+        </p:nvSpPr>
+        <p:spPr>
+          <a:xfrm>
+            <a:off x="274320" y="9326880"/>
             <a:ext cx="11612880" cy="320040"/>
           </a:xfrm>
           <a:prstGeom prst="rect">

</xml_diff>